<commit_message>
Slides: DAG->quotient concept + benchmark gallery; define T + PA-GAP bound
- Add a "from DAG to quotient" concept slide (Synthetic worked example + legend)
  and 3 gallery slides showing each benchmark dataset's fine DAG -> quotient
  C-DAG (ToyGraph/Synth-2, Chain, Epidemiology, Healthcare, Ecology, Protein).
  Figures rendered from code via the coarsening pipeline (slides/render_dag_pngs.py,
  reusing scripts/generate_dataset_dags.py), saved under slides/figures/.
- GAP/PA-GAP slides: define T = number of optimization trials (the budget) and
  add PA-GAP's upper bound 0 <= PA-GAP <= (T+1)/(2T) ~ 0.5 (early-weighting cap).

Co-Authored-By: Claude Opus 4.8 <noreply@anthropic.com>
</commit_message>
<xml_diff>
--- a/slides/GAP_PA-GAP_explainer.pptx
+++ b/slides/GAP_PA-GAP_explainer.pptx
@@ -7,6 +7,10 @@
   <p:sldIdLst>
     <p:sldId id="256" r:id="rId7"/>
     <p:sldId id="257" r:id="rId8"/>
+    <p:sldId id="258" r:id="rId9"/>
+    <p:sldId id="259" r:id="rId10"/>
+    <p:sldId id="260" r:id="rId11"/>
+    <p:sldId id="261" r:id="rId12"/>
   </p:sldIdLst>
   <p:sldSz cx="12191695" cy="6858000" type="screen4x3"/>
   <p:notesSz cx="6858000" cy="9144000"/>
@@ -4564,7 +4568,7 @@
         <p:spPr>
           <a:xfrm>
             <a:off x="6483096" y="2532887"/>
-            <a:ext cx="4864608" cy="1051560"/>
+            <a:ext cx="4864608" cy="960120"/>
           </a:xfrm>
           <a:prstGeom prst="rect">
             <a:avLst/>
@@ -4684,7 +4688,7 @@
                 </a:solidFill>
                 <a:latin typeface="Calibri"/>
               </a:rPr>
-              <a:t>y0 = starting best   ·   y_best = best found   ·   y* = best possible (oracle)   ·   t* = trial best first reached   ·   T = total trials</a:t>
+              <a:t>y0 = starting best   ·   y_best = best found   ·   y* = best possible (oracle)   ·   t* = trial the best was first reached   ·   T = number of optimization trials (the budget)</a:t>
             </a:r>
           </a:p>
         </p:txBody>
@@ -5179,7 +5183,7 @@
                 </a:solidFill>
                 <a:latin typeface="Calibri"/>
               </a:rPr>
-              <a:t>Two methods can reach the same final value but score differently: the one that improves EARLY and holds it wins. PA-GAP = the (early-weighted) area under the improvement curve.</a:t>
+              <a:t>Two methods can reach the same final value but score differently: the one that improves EARLY and holds it wins. Because early trials weigh most, even a perfect run caps near 1/2 (its maximum is (T+1)/(2T)) — so PA-GAP scores look smaller than GAP's 0–1.</a:t>
             </a:r>
           </a:p>
         </p:txBody>
@@ -5193,7 +5197,7 @@
         <p:spPr>
           <a:xfrm>
             <a:off x="6172200" y="1892807"/>
-            <a:ext cx="5486400" cy="2148840"/>
+            <a:ext cx="5486400" cy="2487168"/>
           </a:xfrm>
           <a:prstGeom prst="roundRect">
             <a:avLst>
@@ -5292,7 +5296,7 @@
         <p:spPr>
           <a:xfrm>
             <a:off x="6483096" y="2532887"/>
-            <a:ext cx="4864608" cy="1051560"/>
+            <a:ext cx="4864608" cy="1298448"/>
           </a:xfrm>
           <a:prstGeom prst="rect">
             <a:avLst/>
@@ -5317,13 +5321,13 @@
               </a:spcAft>
             </a:pPr>
             <a:r>
-              <a:rPr sz="1300" b="0">
+              <a:rPr sz="1200" b="0">
                 <a:solidFill>
                   <a:srgbClr val="243242"/>
                 </a:solidFill>
                 <a:latin typeface="Courier New"/>
               </a:rPr>
-              <a:t>R_t = clip( (y0 - best_t) / (y0 - y*),  0, 1)</a:t>
+              <a:t>R_t = clip( (y0 - best_t)/(y0 - y*), 0, 1)</a:t>
             </a:r>
           </a:p>
           <a:p>
@@ -5339,13 +5343,13 @@
               </a:spcAft>
             </a:pPr>
             <a:r>
-              <a:rPr sz="1250" b="0">
+              <a:rPr sz="1200" b="0">
                 <a:solidFill>
                   <a:srgbClr val="243242"/>
                 </a:solidFill>
                 <a:latin typeface="Courier New"/>
               </a:rPr>
-              <a:t>w_t = (T - (t-1)) / T          (early-trial weight)</a:t>
+              <a:t>w_t = (T - (t-1)) / T      (early weight)</a:t>
             </a:r>
           </a:p>
           <a:p>
@@ -5361,7 +5365,7 @@
               </a:spcAft>
             </a:pPr>
             <a:r>
-              <a:rPr sz="1350" b="1">
+              <a:rPr sz="1250" b="1">
                 <a:solidFill>
                   <a:srgbClr val="162A4A"/>
                 </a:solidFill>
@@ -5370,6 +5374,28 @@
               <a:t>PA-GAP = (1/T) · Σ_t  R_t · w_t</a:t>
             </a:r>
           </a:p>
+          <a:p>
+            <a:pPr algn="l">
+              <a:lnSpc>
+                <a:spcPct val="100000"/>
+              </a:lnSpc>
+              <a:spcBef>
+                <a:spcPts val="0"/>
+              </a:spcBef>
+              <a:spcAft>
+                <a:spcPts val="600"/>
+              </a:spcAft>
+            </a:pPr>
+            <a:r>
+              <a:rPr sz="1200" b="1">
+                <a:solidFill>
+                  <a:srgbClr val="C2573A"/>
+                </a:solidFill>
+                <a:latin typeface="Courier New"/>
+              </a:rPr>
+              <a:t>0  &lt;=  PA-GAP  &lt;=  (T+1)/(2T)  ~  0.5</a:t>
+            </a:r>
+          </a:p>
         </p:txBody>
       </p:sp>
       <p:sp>
@@ -5380,7 +5406,7 @@
         </p:nvSpPr>
         <p:spPr>
           <a:xfrm>
-            <a:off x="6483096" y="3474720"/>
+            <a:off x="6483096" y="3813048"/>
             <a:ext cx="4864608" cy="548640"/>
           </a:xfrm>
           <a:prstGeom prst="rect">
@@ -5412,7 +5438,7 @@
                 </a:solidFill>
                 <a:latin typeface="Calibri"/>
               </a:rPr>
-              <a:t>best_t = best-so-far at trial t   ·   R_t = how far you've improved (0–1)   ·   w_t = weight that fades over the run   ·   T = total trials</a:t>
+              <a:t>best_t = best-so-far at trial t   ·   R_t = improvement so far (0–1)   ·   T = number of optimization trials (the budget)</a:t>
             </a:r>
           </a:p>
         </p:txBody>
@@ -5426,8 +5452,8 @@
           <p:nvPr/>
         </p:nvGraphicFramePr>
         <p:xfrm>
-          <a:off x="6217920" y="4224528"/>
-          <a:ext cx="5394960" cy="1874519"/>
+          <a:off x="6217920" y="4562856"/>
+          <a:ext cx="5394960" cy="1536191"/>
         </p:xfrm>
         <a:graphic>
           <a:graphicData uri="http://schemas.openxmlformats.org/drawingml/2006/chart">
@@ -5476,6 +5502,2121 @@
                 <a:latin typeface="Calibri"/>
               </a:rPr>
               <a:t>PA-GAP adds up the shaded area under the whole curve (early trials weighted more) — it rewards the journey, not just the endpoint.</a:t>
+            </a:r>
+          </a:p>
+        </p:txBody>
+      </p:sp>
+    </p:spTree>
+  </p:cSld>
+  <p:clrMapOvr>
+    <a:masterClrMapping/>
+  </p:clrMapOvr>
+</p:sld>
+</file>
+
+<file path=ppt/slides/slide3.xml><?xml version="1.0" encoding="utf-8"?>
+<p:sld xmlns:a="http://schemas.openxmlformats.org/drawingml/2006/main" xmlns:p="http://schemas.openxmlformats.org/presentationml/2006/main" xmlns:r="http://schemas.openxmlformats.org/officeDocument/2006/relationships">
+  <p:cSld>
+    <p:bg>
+      <p:bgPr>
+        <a:solidFill>
+          <a:srgbClr val="FFFFFF"/>
+        </a:solidFill>
+        <a:effectLst/>
+      </p:bgPr>
+    </p:bg>
+    <p:spTree>
+      <p:nvGrpSpPr>
+        <p:cNvPr id="1" name=""/>
+        <p:cNvGrpSpPr/>
+        <p:nvPr/>
+      </p:nvGrpSpPr>
+      <p:grpSpPr/>
+      <p:sp>
+        <p:nvSpPr>
+          <p:cNvPr id="2" name="TextBox 1"/>
+          <p:cNvSpPr txBox="1"/>
+          <p:nvPr/>
+        </p:nvSpPr>
+        <p:spPr>
+          <a:xfrm>
+            <a:off x="548640" y="384048"/>
+            <a:ext cx="11064240" cy="731520"/>
+          </a:xfrm>
+          <a:prstGeom prst="rect">
+            <a:avLst/>
+          </a:prstGeom>
+          <a:noFill/>
+        </p:spPr>
+        <p:txBody>
+          <a:bodyPr wrap="square" anchor="t" lIns="0" rIns="0" tIns="0" bIns="0">
+            <a:spAutoFit/>
+          </a:bodyPr>
+          <a:lstStyle/>
+          <a:p>
+            <a:pPr algn="l">
+              <a:lnSpc>
+                <a:spcPct val="105000"/>
+              </a:lnSpc>
+              <a:spcBef>
+                <a:spcPts val="0"/>
+              </a:spcBef>
+              <a:spcAft>
+                <a:spcPts val="400"/>
+              </a:spcAft>
+            </a:pPr>
+            <a:r>
+              <a:rPr sz="3100" b="1">
+                <a:solidFill>
+                  <a:srgbClr val="162A4A"/>
+                </a:solidFill>
+                <a:latin typeface="Cambria"/>
+              </a:rPr>
+              <a:t>What QCBO operates on: from DAG to quotient</a:t>
+            </a:r>
+          </a:p>
+        </p:txBody>
+      </p:sp>
+      <p:sp>
+        <p:nvSpPr>
+          <p:cNvPr id="3" name="TextBox 2"/>
+          <p:cNvSpPr txBox="1"/>
+          <p:nvPr/>
+        </p:nvSpPr>
+        <p:spPr>
+          <a:xfrm>
+            <a:off x="566928" y="1115568"/>
+            <a:ext cx="11064240" cy="640080"/>
+          </a:xfrm>
+          <a:prstGeom prst="rect">
+            <a:avLst/>
+          </a:prstGeom>
+          <a:noFill/>
+        </p:spPr>
+        <p:txBody>
+          <a:bodyPr wrap="square" anchor="t" lIns="0" rIns="0" tIns="0" bIns="0">
+            <a:spAutoFit/>
+          </a:bodyPr>
+          <a:lstStyle/>
+          <a:p>
+            <a:pPr algn="l">
+              <a:lnSpc>
+                <a:spcPct val="108000"/>
+              </a:lnSpc>
+              <a:spcBef>
+                <a:spcPts val="0"/>
+              </a:spcBef>
+              <a:spcAft>
+                <a:spcPts val="400"/>
+              </a:spcAft>
+            </a:pPr>
+            <a:r>
+              <a:rPr sz="1600" b="0">
+                <a:solidFill>
+                  <a:srgbClr val="5B6B7B"/>
+                </a:solidFill>
+                <a:latin typeface="Calibri"/>
+              </a:rPr>
+              <a:t>QCBO groups the manipulable variables into clusters and reasons over the </a:t>
+            </a:r>
+            <a:r>
+              <a:rPr sz="1600" b="1">
+                <a:solidFill>
+                  <a:srgbClr val="0E8388"/>
+                </a:solidFill>
+                <a:latin typeface="Calibri"/>
+              </a:rPr>
+              <a:t>quotient</a:t>
+            </a:r>
+            <a:r>
+              <a:rPr sz="1600" b="0">
+                <a:solidFill>
+                  <a:srgbClr val="5B6B7B"/>
+                </a:solidFill>
+                <a:latin typeface="Calibri"/>
+              </a:rPr>
+              <a:t> graph — the cluster-level causal graph — instead of the full DAG.</a:t>
+            </a:r>
+          </a:p>
+        </p:txBody>
+      </p:sp>
+      <p:pic>
+        <p:nvPicPr>
+          <p:cNvPr id="4" name="Picture 3" descr="Synthetic_dag.png"/>
+          <p:cNvPicPr>
+            <a:picLocks noChangeAspect="1"/>
+          </p:cNvPicPr>
+          <p:nvPr/>
+        </p:nvPicPr>
+        <p:blipFill>
+          <a:blip r:embed="rId2"/>
+          <a:stretch>
+            <a:fillRect/>
+          </a:stretch>
+        </p:blipFill>
+        <p:spPr>
+          <a:xfrm>
+            <a:off x="1542050" y="1874519"/>
+            <a:ext cx="2310859" cy="3611880"/>
+          </a:xfrm>
+          <a:prstGeom prst="rect">
+            <a:avLst/>
+          </a:prstGeom>
+        </p:spPr>
+      </p:pic>
+      <p:sp>
+        <p:nvSpPr>
+          <p:cNvPr id="5" name="TextBox 4"/>
+          <p:cNvSpPr txBox="1"/>
+          <p:nvPr/>
+        </p:nvSpPr>
+        <p:spPr>
+          <a:xfrm>
+            <a:off x="640080" y="5504688"/>
+            <a:ext cx="4114800" cy="365760"/>
+          </a:xfrm>
+          <a:prstGeom prst="rect">
+            <a:avLst/>
+          </a:prstGeom>
+          <a:noFill/>
+        </p:spPr>
+        <p:txBody>
+          <a:bodyPr wrap="square" anchor="t" lIns="0" rIns="0" tIns="0" bIns="0">
+            <a:spAutoFit/>
+          </a:bodyPr>
+          <a:lstStyle/>
+          <a:p>
+            <a:pPr algn="ctr">
+              <a:lnSpc>
+                <a:spcPct val="105000"/>
+              </a:lnSpc>
+              <a:spcBef>
+                <a:spcPts val="0"/>
+              </a:spcBef>
+              <a:spcAft>
+                <a:spcPts val="400"/>
+              </a:spcAft>
+            </a:pPr>
+            <a:r>
+              <a:rPr sz="1300" b="0">
+                <a:solidFill>
+                  <a:srgbClr val="5B6B7B"/>
+                </a:solidFill>
+                <a:latin typeface="Calibri"/>
+              </a:rPr>
+              <a:t>Full causal DAG  (Synthetic / CompleteGraph)</a:t>
+            </a:r>
+          </a:p>
+        </p:txBody>
+      </p:sp>
+      <p:sp>
+        <p:nvSpPr>
+          <p:cNvPr id="6" name="TextBox 5"/>
+          <p:cNvSpPr txBox="1"/>
+          <p:nvPr/>
+        </p:nvSpPr>
+        <p:spPr>
+          <a:xfrm>
+            <a:off x="4709160" y="2788920"/>
+            <a:ext cx="2743200" cy="731520"/>
+          </a:xfrm>
+          <a:prstGeom prst="rect">
+            <a:avLst/>
+          </a:prstGeom>
+          <a:noFill/>
+        </p:spPr>
+        <p:txBody>
+          <a:bodyPr wrap="square" anchor="ctr" lIns="0" rIns="0" tIns="0" bIns="0">
+            <a:spAutoFit/>
+          </a:bodyPr>
+          <a:lstStyle/>
+          <a:p>
+            <a:pPr algn="ctr">
+              <a:lnSpc>
+                <a:spcPct val="105000"/>
+              </a:lnSpc>
+              <a:spcBef>
+                <a:spcPts val="0"/>
+              </a:spcBef>
+              <a:spcAft>
+                <a:spcPts val="400"/>
+              </a:spcAft>
+            </a:pPr>
+            <a:r>
+              <a:rPr sz="4400" b="1">
+                <a:solidFill>
+                  <a:srgbClr val="0E8388"/>
+                </a:solidFill>
+                <a:latin typeface="Calibri"/>
+              </a:rPr>
+              <a:t>→</a:t>
+            </a:r>
+          </a:p>
+        </p:txBody>
+      </p:sp>
+      <p:sp>
+        <p:nvSpPr>
+          <p:cNvPr id="7" name="TextBox 6"/>
+          <p:cNvSpPr txBox="1"/>
+          <p:nvPr/>
+        </p:nvSpPr>
+        <p:spPr>
+          <a:xfrm>
+            <a:off x="4709160" y="3611880"/>
+            <a:ext cx="2743200" cy="457200"/>
+          </a:xfrm>
+          <a:prstGeom prst="rect">
+            <a:avLst/>
+          </a:prstGeom>
+          <a:noFill/>
+        </p:spPr>
+        <p:txBody>
+          <a:bodyPr wrap="square" anchor="t" lIns="0" rIns="0" tIns="0" bIns="0">
+            <a:spAutoFit/>
+          </a:bodyPr>
+          <a:lstStyle/>
+          <a:p>
+            <a:pPr algn="ctr">
+              <a:lnSpc>
+                <a:spcPct val="105000"/>
+              </a:lnSpc>
+              <a:spcBef>
+                <a:spcPts val="0"/>
+              </a:spcBef>
+              <a:spcAft>
+                <a:spcPts val="400"/>
+              </a:spcAft>
+            </a:pPr>
+            <a:r>
+              <a:rPr sz="1500" b="1">
+                <a:solidFill>
+                  <a:srgbClr val="162A4A"/>
+                </a:solidFill>
+                <a:latin typeface="Calibri"/>
+              </a:rPr>
+              <a:t>merge  {D, E}</a:t>
+            </a:r>
+          </a:p>
+        </p:txBody>
+      </p:sp>
+      <p:pic>
+        <p:nvPicPr>
+          <p:cNvPr id="8" name="Picture 7" descr="Synthetic_cdag.png"/>
+          <p:cNvPicPr>
+            <a:picLocks noChangeAspect="1"/>
+          </p:cNvPicPr>
+          <p:nvPr/>
+        </p:nvPicPr>
+        <p:blipFill>
+          <a:blip r:embed="rId3"/>
+          <a:stretch>
+            <a:fillRect/>
+          </a:stretch>
+        </p:blipFill>
+        <p:spPr>
+          <a:xfrm>
+            <a:off x="8308610" y="1874519"/>
+            <a:ext cx="2310859" cy="3611880"/>
+          </a:xfrm>
+          <a:prstGeom prst="rect">
+            <a:avLst/>
+          </a:prstGeom>
+        </p:spPr>
+      </p:pic>
+      <p:sp>
+        <p:nvSpPr>
+          <p:cNvPr id="9" name="TextBox 8"/>
+          <p:cNvSpPr txBox="1"/>
+          <p:nvPr/>
+        </p:nvSpPr>
+        <p:spPr>
+          <a:xfrm>
+            <a:off x="7406640" y="5504688"/>
+            <a:ext cx="4114800" cy="365760"/>
+          </a:xfrm>
+          <a:prstGeom prst="rect">
+            <a:avLst/>
+          </a:prstGeom>
+          <a:noFill/>
+        </p:spPr>
+        <p:txBody>
+          <a:bodyPr wrap="square" anchor="t" lIns="0" rIns="0" tIns="0" bIns="0">
+            <a:spAutoFit/>
+          </a:bodyPr>
+          <a:lstStyle/>
+          <a:p>
+            <a:pPr algn="ctr">
+              <a:lnSpc>
+                <a:spcPct val="105000"/>
+              </a:lnSpc>
+              <a:spcBef>
+                <a:spcPts val="0"/>
+              </a:spcBef>
+              <a:spcAft>
+                <a:spcPts val="400"/>
+              </a:spcAft>
+            </a:pPr>
+            <a:r>
+              <a:rPr sz="1300" b="1">
+                <a:solidFill>
+                  <a:srgbClr val="0E8388"/>
+                </a:solidFill>
+                <a:latin typeface="Calibri"/>
+              </a:rPr>
+              <a:t>Quotient C-DAG  (what QCBO uses)</a:t>
+            </a:r>
+          </a:p>
+        </p:txBody>
+      </p:sp>
+      <p:sp>
+        <p:nvSpPr>
+          <p:cNvPr id="10" name="Oval 9"/>
+          <p:cNvSpPr/>
+          <p:nvPr/>
+        </p:nvSpPr>
+        <p:spPr>
+          <a:xfrm>
+            <a:off x="960120" y="6144768"/>
+            <a:ext cx="201168" cy="201168"/>
+          </a:xfrm>
+          <a:prstGeom prst="ellipse">
+            <a:avLst/>
+          </a:prstGeom>
+          <a:solidFill>
+            <a:srgbClr val="E0763A"/>
+          </a:solidFill>
+          <a:ln>
+            <a:noFill/>
+          </a:ln>
+          <a:effectLst/>
+        </p:spPr>
+        <p:style>
+          <a:lnRef idx="1">
+            <a:schemeClr val="accent1"/>
+          </a:lnRef>
+          <a:fillRef idx="3">
+            <a:schemeClr val="accent1"/>
+          </a:fillRef>
+          <a:effectRef idx="2">
+            <a:schemeClr val="accent1"/>
+          </a:effectRef>
+          <a:fontRef idx="minor">
+            <a:schemeClr val="lt1"/>
+          </a:fontRef>
+        </p:style>
+        <p:txBody>
+          <a:bodyPr rtlCol="0" anchor="ctr"/>
+          <a:lstStyle/>
+          <a:p>
+            <a:pPr algn="ctr"/>
+          </a:p>
+        </p:txBody>
+      </p:sp>
+      <p:sp>
+        <p:nvSpPr>
+          <p:cNvPr id="11" name="TextBox 10"/>
+          <p:cNvSpPr txBox="1"/>
+          <p:nvPr/>
+        </p:nvSpPr>
+        <p:spPr>
+          <a:xfrm>
+            <a:off x="1271016" y="6099048"/>
+            <a:ext cx="952804" cy="292608"/>
+          </a:xfrm>
+          <a:prstGeom prst="rect">
+            <a:avLst/>
+          </a:prstGeom>
+          <a:noFill/>
+        </p:spPr>
+        <p:txBody>
+          <a:bodyPr wrap="square" anchor="ctr" lIns="0" rIns="0" tIns="0" bIns="0">
+            <a:spAutoFit/>
+          </a:bodyPr>
+          <a:lstStyle/>
+          <a:p>
+            <a:pPr algn="l">
+              <a:lnSpc>
+                <a:spcPct val="105000"/>
+              </a:lnSpc>
+              <a:spcBef>
+                <a:spcPts val="0"/>
+              </a:spcBef>
+              <a:spcAft>
+                <a:spcPts val="400"/>
+              </a:spcAft>
+            </a:pPr>
+            <a:r>
+              <a:rPr sz="1150" b="0">
+                <a:solidFill>
+                  <a:srgbClr val="243242"/>
+                </a:solidFill>
+                <a:latin typeface="Calibri"/>
+              </a:rPr>
+              <a:t>manipulable</a:t>
+            </a:r>
+          </a:p>
+        </p:txBody>
+      </p:sp>
+      <p:sp>
+        <p:nvSpPr>
+          <p:cNvPr id="12" name="Oval 11"/>
+          <p:cNvSpPr/>
+          <p:nvPr/>
+        </p:nvSpPr>
+        <p:spPr>
+          <a:xfrm>
+            <a:off x="2534716" y="6144768"/>
+            <a:ext cx="201168" cy="201168"/>
+          </a:xfrm>
+          <a:prstGeom prst="ellipse">
+            <a:avLst/>
+          </a:prstGeom>
+          <a:solidFill>
+            <a:srgbClr val="7FB2D4"/>
+          </a:solidFill>
+          <a:ln>
+            <a:noFill/>
+          </a:ln>
+          <a:effectLst/>
+        </p:spPr>
+        <p:style>
+          <a:lnRef idx="1">
+            <a:schemeClr val="accent1"/>
+          </a:lnRef>
+          <a:fillRef idx="3">
+            <a:schemeClr val="accent1"/>
+          </a:fillRef>
+          <a:effectRef idx="2">
+            <a:schemeClr val="accent1"/>
+          </a:effectRef>
+          <a:fontRef idx="minor">
+            <a:schemeClr val="lt1"/>
+          </a:fontRef>
+        </p:style>
+        <p:txBody>
+          <a:bodyPr rtlCol="0" anchor="ctr"/>
+          <a:lstStyle/>
+          <a:p>
+            <a:pPr algn="ctr"/>
+          </a:p>
+        </p:txBody>
+      </p:sp>
+      <p:sp>
+        <p:nvSpPr>
+          <p:cNvPr id="13" name="TextBox 12"/>
+          <p:cNvSpPr txBox="1"/>
+          <p:nvPr/>
+        </p:nvSpPr>
+        <p:spPr>
+          <a:xfrm>
+            <a:off x="2845612" y="6099048"/>
+            <a:ext cx="1177747" cy="292608"/>
+          </a:xfrm>
+          <a:prstGeom prst="rect">
+            <a:avLst/>
+          </a:prstGeom>
+          <a:noFill/>
+        </p:spPr>
+        <p:txBody>
+          <a:bodyPr wrap="square" anchor="ctr" lIns="0" rIns="0" tIns="0" bIns="0">
+            <a:spAutoFit/>
+          </a:bodyPr>
+          <a:lstStyle/>
+          <a:p>
+            <a:pPr algn="l">
+              <a:lnSpc>
+                <a:spcPct val="105000"/>
+              </a:lnSpc>
+              <a:spcBef>
+                <a:spcPts val="0"/>
+              </a:spcBef>
+              <a:spcAft>
+                <a:spcPts val="400"/>
+              </a:spcAft>
+            </a:pPr>
+            <a:r>
+              <a:rPr sz="1150" b="0">
+                <a:solidFill>
+                  <a:srgbClr val="243242"/>
+                </a:solidFill>
+                <a:latin typeface="Calibri"/>
+              </a:rPr>
+              <a:t>other variable</a:t>
+            </a:r>
+          </a:p>
+        </p:txBody>
+      </p:sp>
+      <p:sp>
+        <p:nvSpPr>
+          <p:cNvPr id="14" name="Oval 13"/>
+          <p:cNvSpPr/>
+          <p:nvPr/>
+        </p:nvSpPr>
+        <p:spPr>
+          <a:xfrm>
+            <a:off x="4334256" y="6144768"/>
+            <a:ext cx="201168" cy="201168"/>
+          </a:xfrm>
+          <a:prstGeom prst="ellipse">
+            <a:avLst/>
+          </a:prstGeom>
+          <a:solidFill>
+            <a:srgbClr val="CDE05A"/>
+          </a:solidFill>
+          <a:ln>
+            <a:noFill/>
+          </a:ln>
+          <a:effectLst/>
+        </p:spPr>
+        <p:style>
+          <a:lnRef idx="1">
+            <a:schemeClr val="accent1"/>
+          </a:lnRef>
+          <a:fillRef idx="3">
+            <a:schemeClr val="accent1"/>
+          </a:fillRef>
+          <a:effectRef idx="2">
+            <a:schemeClr val="accent1"/>
+          </a:effectRef>
+          <a:fontRef idx="minor">
+            <a:schemeClr val="lt1"/>
+          </a:fontRef>
+        </p:style>
+        <p:txBody>
+          <a:bodyPr rtlCol="0" anchor="ctr"/>
+          <a:lstStyle/>
+          <a:p>
+            <a:pPr algn="ctr"/>
+          </a:p>
+        </p:txBody>
+      </p:sp>
+      <p:sp>
+        <p:nvSpPr>
+          <p:cNvPr id="15" name="TextBox 14"/>
+          <p:cNvSpPr txBox="1"/>
+          <p:nvPr/>
+        </p:nvSpPr>
+        <p:spPr>
+          <a:xfrm>
+            <a:off x="4645152" y="6099048"/>
+            <a:ext cx="727862" cy="292608"/>
+          </a:xfrm>
+          <a:prstGeom prst="rect">
+            <a:avLst/>
+          </a:prstGeom>
+          <a:noFill/>
+        </p:spPr>
+        <p:txBody>
+          <a:bodyPr wrap="square" anchor="ctr" lIns="0" rIns="0" tIns="0" bIns="0">
+            <a:spAutoFit/>
+          </a:bodyPr>
+          <a:lstStyle/>
+          <a:p>
+            <a:pPr algn="l">
+              <a:lnSpc>
+                <a:spcPct val="105000"/>
+              </a:lnSpc>
+              <a:spcBef>
+                <a:spcPts val="0"/>
+              </a:spcBef>
+              <a:spcAft>
+                <a:spcPts val="400"/>
+              </a:spcAft>
+            </a:pPr>
+            <a:r>
+              <a:rPr sz="1150" b="0">
+                <a:solidFill>
+                  <a:srgbClr val="243242"/>
+                </a:solidFill>
+                <a:latin typeface="Calibri"/>
+              </a:rPr>
+              <a:t>target Y</a:t>
+            </a:r>
+          </a:p>
+        </p:txBody>
+      </p:sp>
+      <p:sp>
+        <p:nvSpPr>
+          <p:cNvPr id="16" name="Rounded Rectangle 15"/>
+          <p:cNvSpPr/>
+          <p:nvPr/>
+        </p:nvSpPr>
+        <p:spPr>
+          <a:xfrm>
+            <a:off x="5683910" y="6163055"/>
+            <a:ext cx="310896" cy="164592"/>
+          </a:xfrm>
+          <a:prstGeom prst="roundRect">
+            <a:avLst/>
+          </a:prstGeom>
+          <a:solidFill>
+            <a:srgbClr val="E0763A"/>
+          </a:solidFill>
+          <a:ln>
+            <a:noFill/>
+          </a:ln>
+          <a:effectLst/>
+        </p:spPr>
+        <p:style>
+          <a:lnRef idx="1">
+            <a:schemeClr val="accent1"/>
+          </a:lnRef>
+          <a:fillRef idx="3">
+            <a:schemeClr val="accent1"/>
+          </a:fillRef>
+          <a:effectRef idx="2">
+            <a:schemeClr val="accent1"/>
+          </a:effectRef>
+          <a:fontRef idx="minor">
+            <a:schemeClr val="lt1"/>
+          </a:fontRef>
+        </p:style>
+        <p:txBody>
+          <a:bodyPr rtlCol="0" anchor="ctr"/>
+          <a:lstStyle/>
+          <a:p>
+            <a:pPr algn="ctr"/>
+          </a:p>
+        </p:txBody>
+      </p:sp>
+      <p:sp>
+        <p:nvSpPr>
+          <p:cNvPr id="17" name="TextBox 16"/>
+          <p:cNvSpPr txBox="1"/>
+          <p:nvPr/>
+        </p:nvSpPr>
+        <p:spPr>
+          <a:xfrm>
+            <a:off x="6104534" y="6099048"/>
+            <a:ext cx="1477670" cy="292608"/>
+          </a:xfrm>
+          <a:prstGeom prst="rect">
+            <a:avLst/>
+          </a:prstGeom>
+          <a:noFill/>
+        </p:spPr>
+        <p:txBody>
+          <a:bodyPr wrap="square" anchor="ctr" lIns="0" rIns="0" tIns="0" bIns="0">
+            <a:spAutoFit/>
+          </a:bodyPr>
+          <a:lstStyle/>
+          <a:p>
+            <a:pPr algn="l">
+              <a:lnSpc>
+                <a:spcPct val="105000"/>
+              </a:lnSpc>
+              <a:spcBef>
+                <a:spcPts val="0"/>
+              </a:spcBef>
+              <a:spcAft>
+                <a:spcPts val="400"/>
+              </a:spcAft>
+            </a:pPr>
+            <a:r>
+              <a:rPr sz="1150" b="0">
+                <a:solidFill>
+                  <a:srgbClr val="243242"/>
+                </a:solidFill>
+                <a:latin typeface="Calibri"/>
+              </a:rPr>
+              <a:t>cluster (quotient)</a:t>
+            </a:r>
+          </a:p>
+        </p:txBody>
+      </p:sp>
+      <p:sp>
+        <p:nvSpPr>
+          <p:cNvPr id="18" name="Rectangle 17"/>
+          <p:cNvSpPr/>
+          <p:nvPr/>
+        </p:nvSpPr>
+        <p:spPr>
+          <a:xfrm>
+            <a:off x="7893100" y="6227064"/>
+            <a:ext cx="274320" cy="41148"/>
+          </a:xfrm>
+          <a:prstGeom prst="rect">
+            <a:avLst/>
+          </a:prstGeom>
+          <a:solidFill>
+            <a:srgbClr val="B3202C"/>
+          </a:solidFill>
+          <a:ln>
+            <a:noFill/>
+          </a:ln>
+          <a:effectLst/>
+        </p:spPr>
+        <p:style>
+          <a:lnRef idx="1">
+            <a:schemeClr val="accent1"/>
+          </a:lnRef>
+          <a:fillRef idx="3">
+            <a:schemeClr val="accent1"/>
+          </a:fillRef>
+          <a:effectRef idx="2">
+            <a:schemeClr val="accent1"/>
+          </a:effectRef>
+          <a:fontRef idx="minor">
+            <a:schemeClr val="lt1"/>
+          </a:fontRef>
+        </p:style>
+        <p:txBody>
+          <a:bodyPr rtlCol="0" anchor="ctr"/>
+          <a:lstStyle/>
+          <a:p>
+            <a:pPr algn="ctr"/>
+          </a:p>
+        </p:txBody>
+      </p:sp>
+      <p:sp>
+        <p:nvSpPr>
+          <p:cNvPr id="19" name="TextBox 18"/>
+          <p:cNvSpPr txBox="1"/>
+          <p:nvPr/>
+        </p:nvSpPr>
+        <p:spPr>
+          <a:xfrm>
+            <a:off x="8277148" y="6099048"/>
+            <a:ext cx="1402689" cy="292608"/>
+          </a:xfrm>
+          <a:prstGeom prst="rect">
+            <a:avLst/>
+          </a:prstGeom>
+          <a:noFill/>
+        </p:spPr>
+        <p:txBody>
+          <a:bodyPr wrap="square" anchor="ctr" lIns="0" rIns="0" tIns="0" bIns="0">
+            <a:spAutoFit/>
+          </a:bodyPr>
+          <a:lstStyle/>
+          <a:p>
+            <a:pPr algn="l">
+              <a:lnSpc>
+                <a:spcPct val="105000"/>
+              </a:lnSpc>
+              <a:spcBef>
+                <a:spcPts val="0"/>
+              </a:spcBef>
+              <a:spcAft>
+                <a:spcPts val="400"/>
+              </a:spcAft>
+            </a:pPr>
+            <a:r>
+              <a:rPr sz="1150" b="0">
+                <a:solidFill>
+                  <a:srgbClr val="243242"/>
+                </a:solidFill>
+                <a:latin typeface="Calibri"/>
+              </a:rPr>
+              <a:t>latent confounder</a:t>
+            </a:r>
+          </a:p>
+        </p:txBody>
+      </p:sp>
+    </p:spTree>
+  </p:cSld>
+  <p:clrMapOvr>
+    <a:masterClrMapping/>
+  </p:clrMapOvr>
+</p:sld>
+</file>
+
+<file path=ppt/slides/slide4.xml><?xml version="1.0" encoding="utf-8"?>
+<p:sld xmlns:a="http://schemas.openxmlformats.org/drawingml/2006/main" xmlns:p="http://schemas.openxmlformats.org/presentationml/2006/main" xmlns:r="http://schemas.openxmlformats.org/officeDocument/2006/relationships">
+  <p:cSld>
+    <p:bg>
+      <p:bgPr>
+        <a:solidFill>
+          <a:srgbClr val="FFFFFF"/>
+        </a:solidFill>
+        <a:effectLst/>
+      </p:bgPr>
+    </p:bg>
+    <p:spTree>
+      <p:nvGrpSpPr>
+        <p:cNvPr id="1" name=""/>
+        <p:cNvGrpSpPr/>
+        <p:nvPr/>
+      </p:nvGrpSpPr>
+      <p:grpSpPr/>
+      <p:sp>
+        <p:nvSpPr>
+          <p:cNvPr id="2" name="TextBox 1"/>
+          <p:cNvSpPr txBox="1"/>
+          <p:nvPr/>
+        </p:nvSpPr>
+        <p:spPr>
+          <a:xfrm>
+            <a:off x="548640" y="384048"/>
+            <a:ext cx="11064240" cy="731520"/>
+          </a:xfrm>
+          <a:prstGeom prst="rect">
+            <a:avLst/>
+          </a:prstGeom>
+          <a:noFill/>
+        </p:spPr>
+        <p:txBody>
+          <a:bodyPr wrap="square" anchor="t" lIns="0" rIns="0" tIns="0" bIns="0">
+            <a:spAutoFit/>
+          </a:bodyPr>
+          <a:lstStyle/>
+          <a:p>
+            <a:pPr algn="l">
+              <a:lnSpc>
+                <a:spcPct val="105000"/>
+              </a:lnSpc>
+              <a:spcBef>
+                <a:spcPts val="0"/>
+              </a:spcBef>
+              <a:spcAft>
+                <a:spcPts val="400"/>
+              </a:spcAft>
+            </a:pPr>
+            <a:r>
+              <a:rPr sz="2800" b="1">
+                <a:solidFill>
+                  <a:srgbClr val="162A4A"/>
+                </a:solidFill>
+                <a:latin typeface="Cambria"/>
+              </a:rPr>
+              <a:t>Benchmark structures and their quotients  (1 / 3)</a:t>
+            </a:r>
+          </a:p>
+        </p:txBody>
+      </p:sp>
+      <p:sp>
+        <p:nvSpPr>
+          <p:cNvPr id="3" name="TextBox 2"/>
+          <p:cNvSpPr txBox="1"/>
+          <p:nvPr/>
+        </p:nvSpPr>
+        <p:spPr>
+          <a:xfrm>
+            <a:off x="502920" y="1371600"/>
+            <a:ext cx="2331720" cy="2583180"/>
+          </a:xfrm>
+          <a:prstGeom prst="rect">
+            <a:avLst/>
+          </a:prstGeom>
+          <a:noFill/>
+        </p:spPr>
+        <p:txBody>
+          <a:bodyPr wrap="square" anchor="ctr" lIns="0" rIns="0" tIns="0" bIns="0">
+            <a:spAutoFit/>
+          </a:bodyPr>
+          <a:lstStyle/>
+          <a:p>
+            <a:pPr algn="l">
+              <a:lnSpc>
+                <a:spcPct val="105000"/>
+              </a:lnSpc>
+              <a:spcBef>
+                <a:spcPts val="0"/>
+              </a:spcBef>
+              <a:spcAft>
+                <a:spcPts val="300"/>
+              </a:spcAft>
+            </a:pPr>
+            <a:r>
+              <a:rPr sz="1700" b="1">
+                <a:solidFill>
+                  <a:srgbClr val="162A4A"/>
+                </a:solidFill>
+                <a:latin typeface="Calibri"/>
+              </a:rPr>
+              <a:t>ToyGraph / Synth-2</a:t>
+            </a:r>
+          </a:p>
+          <a:p>
+            <a:pPr algn="l">
+              <a:lnSpc>
+                <a:spcPct val="105000"/>
+              </a:lnSpc>
+              <a:spcBef>
+                <a:spcPts val="0"/>
+              </a:spcBef>
+              <a:spcAft>
+                <a:spcPts val="300"/>
+              </a:spcAft>
+            </a:pPr>
+            <a:r>
+              <a:rPr sz="1200" b="0">
+                <a:solidFill>
+                  <a:srgbClr val="5B6B7B"/>
+                </a:solidFill>
+                <a:latin typeface="Calibri"/>
+              </a:rPr>
+              <a:t>cluster {X, Z}</a:t>
+            </a:r>
+          </a:p>
+        </p:txBody>
+      </p:sp>
+      <p:pic>
+        <p:nvPicPr>
+          <p:cNvPr id="4" name="Picture 3" descr="ToyGraph_dag.png"/>
+          <p:cNvPicPr>
+            <a:picLocks noChangeAspect="1"/>
+          </p:cNvPicPr>
+          <p:nvPr/>
+        </p:nvPicPr>
+        <p:blipFill>
+          <a:blip r:embed="rId2"/>
+          <a:stretch>
+            <a:fillRect/>
+          </a:stretch>
+        </p:blipFill>
+        <p:spPr>
+          <a:xfrm>
+            <a:off x="3755117" y="1463040"/>
+            <a:ext cx="1450884" cy="2272284"/>
+          </a:xfrm>
+          <a:prstGeom prst="rect">
+            <a:avLst/>
+          </a:prstGeom>
+        </p:spPr>
+      </p:pic>
+      <p:sp>
+        <p:nvSpPr>
+          <p:cNvPr id="5" name="TextBox 4"/>
+          <p:cNvSpPr txBox="1"/>
+          <p:nvPr/>
+        </p:nvSpPr>
+        <p:spPr>
+          <a:xfrm>
+            <a:off x="6126480" y="1371600"/>
+            <a:ext cx="640080" cy="2583180"/>
+          </a:xfrm>
+          <a:prstGeom prst="rect">
+            <a:avLst/>
+          </a:prstGeom>
+          <a:noFill/>
+        </p:spPr>
+        <p:txBody>
+          <a:bodyPr wrap="square" anchor="ctr" lIns="0" rIns="0" tIns="0" bIns="0">
+            <a:spAutoFit/>
+          </a:bodyPr>
+          <a:lstStyle/>
+          <a:p>
+            <a:pPr algn="ctr">
+              <a:lnSpc>
+                <a:spcPct val="105000"/>
+              </a:lnSpc>
+              <a:spcBef>
+                <a:spcPts val="0"/>
+              </a:spcBef>
+              <a:spcAft>
+                <a:spcPts val="400"/>
+              </a:spcAft>
+            </a:pPr>
+            <a:r>
+              <a:rPr sz="2600" b="1">
+                <a:solidFill>
+                  <a:srgbClr val="0E8388"/>
+                </a:solidFill>
+                <a:latin typeface="Calibri"/>
+              </a:rPr>
+              <a:t>→</a:t>
+            </a:r>
+          </a:p>
+        </p:txBody>
+      </p:sp>
+      <p:pic>
+        <p:nvPicPr>
+          <p:cNvPr id="6" name="Picture 5" descr="ToyGraph_cdag.png"/>
+          <p:cNvPicPr>
+            <a:picLocks noChangeAspect="1"/>
+          </p:cNvPicPr>
+          <p:nvPr/>
+        </p:nvPicPr>
+        <p:blipFill>
+          <a:blip r:embed="rId3"/>
+          <a:stretch>
+            <a:fillRect/>
+          </a:stretch>
+        </p:blipFill>
+        <p:spPr>
+          <a:xfrm>
+            <a:off x="7402146" y="1463040"/>
+            <a:ext cx="2112106" cy="2272284"/>
+          </a:xfrm>
+          <a:prstGeom prst="rect">
+            <a:avLst/>
+          </a:prstGeom>
+        </p:spPr>
+      </p:pic>
+      <p:sp>
+        <p:nvSpPr>
+          <p:cNvPr id="7" name="TextBox 6"/>
+          <p:cNvSpPr txBox="1"/>
+          <p:nvPr/>
+        </p:nvSpPr>
+        <p:spPr>
+          <a:xfrm>
+            <a:off x="502920" y="3954780"/>
+            <a:ext cx="2331720" cy="2583180"/>
+          </a:xfrm>
+          <a:prstGeom prst="rect">
+            <a:avLst/>
+          </a:prstGeom>
+          <a:noFill/>
+        </p:spPr>
+        <p:txBody>
+          <a:bodyPr wrap="square" anchor="ctr" lIns="0" rIns="0" tIns="0" bIns="0">
+            <a:spAutoFit/>
+          </a:bodyPr>
+          <a:lstStyle/>
+          <a:p>
+            <a:pPr algn="l">
+              <a:lnSpc>
+                <a:spcPct val="105000"/>
+              </a:lnSpc>
+              <a:spcBef>
+                <a:spcPts val="0"/>
+              </a:spcBef>
+              <a:spcAft>
+                <a:spcPts val="300"/>
+              </a:spcAft>
+            </a:pPr>
+            <a:r>
+              <a:rPr sz="1700" b="1">
+                <a:solidFill>
+                  <a:srgbClr val="162A4A"/>
+                </a:solidFill>
+                <a:latin typeface="Calibri"/>
+              </a:rPr>
+              <a:t>Chain-hard</a:t>
+            </a:r>
+          </a:p>
+          <a:p>
+            <a:pPr algn="l">
+              <a:lnSpc>
+                <a:spcPct val="105000"/>
+              </a:lnSpc>
+              <a:spcBef>
+                <a:spcPts val="0"/>
+              </a:spcBef>
+              <a:spcAft>
+                <a:spcPts val="300"/>
+              </a:spcAft>
+            </a:pPr>
+            <a:r>
+              <a:rPr sz="1200" b="0">
+                <a:solidFill>
+                  <a:srgbClr val="5B6B7B"/>
+                </a:solidFill>
+                <a:latin typeface="Calibri"/>
+              </a:rPr>
+              <a:t>cluster {Z, W}</a:t>
+            </a:r>
+          </a:p>
+        </p:txBody>
+      </p:sp>
+      <p:pic>
+        <p:nvPicPr>
+          <p:cNvPr id="8" name="Picture 7" descr="Chain_dag.png"/>
+          <p:cNvPicPr>
+            <a:picLocks noChangeAspect="1"/>
+          </p:cNvPicPr>
+          <p:nvPr/>
+        </p:nvPicPr>
+        <p:blipFill>
+          <a:blip r:embed="rId4"/>
+          <a:stretch>
+            <a:fillRect/>
+          </a:stretch>
+        </p:blipFill>
+        <p:spPr>
+          <a:xfrm>
+            <a:off x="3526098" y="4046220"/>
+            <a:ext cx="1908923" cy="2272284"/>
+          </a:xfrm>
+          <a:prstGeom prst="rect">
+            <a:avLst/>
+          </a:prstGeom>
+        </p:spPr>
+      </p:pic>
+      <p:sp>
+        <p:nvSpPr>
+          <p:cNvPr id="9" name="TextBox 8"/>
+          <p:cNvSpPr txBox="1"/>
+          <p:nvPr/>
+        </p:nvSpPr>
+        <p:spPr>
+          <a:xfrm>
+            <a:off x="6126480" y="3954780"/>
+            <a:ext cx="640080" cy="2583180"/>
+          </a:xfrm>
+          <a:prstGeom prst="rect">
+            <a:avLst/>
+          </a:prstGeom>
+          <a:noFill/>
+        </p:spPr>
+        <p:txBody>
+          <a:bodyPr wrap="square" anchor="ctr" lIns="0" rIns="0" tIns="0" bIns="0">
+            <a:spAutoFit/>
+          </a:bodyPr>
+          <a:lstStyle/>
+          <a:p>
+            <a:pPr algn="ctr">
+              <a:lnSpc>
+                <a:spcPct val="105000"/>
+              </a:lnSpc>
+              <a:spcBef>
+                <a:spcPts val="0"/>
+              </a:spcBef>
+              <a:spcAft>
+                <a:spcPts val="400"/>
+              </a:spcAft>
+            </a:pPr>
+            <a:r>
+              <a:rPr sz="2600" b="1">
+                <a:solidFill>
+                  <a:srgbClr val="0E8388"/>
+                </a:solidFill>
+                <a:latin typeface="Calibri"/>
+              </a:rPr>
+              <a:t>→</a:t>
+            </a:r>
+          </a:p>
+        </p:txBody>
+      </p:sp>
+      <p:pic>
+        <p:nvPicPr>
+          <p:cNvPr id="10" name="Picture 9" descr="Chain_cdag.png"/>
+          <p:cNvPicPr>
+            <a:picLocks noChangeAspect="1"/>
+          </p:cNvPicPr>
+          <p:nvPr/>
+        </p:nvPicPr>
+        <p:blipFill>
+          <a:blip r:embed="rId5"/>
+          <a:stretch>
+            <a:fillRect/>
+          </a:stretch>
+        </p:blipFill>
+        <p:spPr>
+          <a:xfrm>
+            <a:off x="7732757" y="4046220"/>
+            <a:ext cx="1450884" cy="2272284"/>
+          </a:xfrm>
+          <a:prstGeom prst="rect">
+            <a:avLst/>
+          </a:prstGeom>
+        </p:spPr>
+      </p:pic>
+      <p:sp>
+        <p:nvSpPr>
+          <p:cNvPr id="11" name="TextBox 10"/>
+          <p:cNvSpPr txBox="1"/>
+          <p:nvPr/>
+        </p:nvSpPr>
+        <p:spPr>
+          <a:xfrm>
+            <a:off x="548640" y="6510528"/>
+            <a:ext cx="11064240" cy="292608"/>
+          </a:xfrm>
+          <a:prstGeom prst="rect">
+            <a:avLst/>
+          </a:prstGeom>
+          <a:noFill/>
+        </p:spPr>
+        <p:txBody>
+          <a:bodyPr wrap="square" anchor="t" lIns="0" rIns="0" tIns="0" bIns="0">
+            <a:spAutoFit/>
+          </a:bodyPr>
+          <a:lstStyle/>
+          <a:p>
+            <a:pPr algn="ctr">
+              <a:lnSpc>
+                <a:spcPct val="105000"/>
+              </a:lnSpc>
+              <a:spcBef>
+                <a:spcPts val="0"/>
+              </a:spcBef>
+              <a:spcAft>
+                <a:spcPts val="400"/>
+              </a:spcAft>
+            </a:pPr>
+            <a:r>
+              <a:rPr sz="1100" b="0" i="1">
+                <a:solidFill>
+                  <a:srgbClr val="5B6B7B"/>
+                </a:solidFill>
+                <a:latin typeface="Calibri"/>
+              </a:rPr>
+              <a:t>fine DAG  →  quotient C-DAG   (orange = manipulable, box = cluster, dashed red = latent confounder)</a:t>
+            </a:r>
+          </a:p>
+        </p:txBody>
+      </p:sp>
+    </p:spTree>
+  </p:cSld>
+  <p:clrMapOvr>
+    <a:masterClrMapping/>
+  </p:clrMapOvr>
+</p:sld>
+</file>
+
+<file path=ppt/slides/slide5.xml><?xml version="1.0" encoding="utf-8"?>
+<p:sld xmlns:a="http://schemas.openxmlformats.org/drawingml/2006/main" xmlns:p="http://schemas.openxmlformats.org/presentationml/2006/main" xmlns:r="http://schemas.openxmlformats.org/officeDocument/2006/relationships">
+  <p:cSld>
+    <p:bg>
+      <p:bgPr>
+        <a:solidFill>
+          <a:srgbClr val="FFFFFF"/>
+        </a:solidFill>
+        <a:effectLst/>
+      </p:bgPr>
+    </p:bg>
+    <p:spTree>
+      <p:nvGrpSpPr>
+        <p:cNvPr id="1" name=""/>
+        <p:cNvGrpSpPr/>
+        <p:nvPr/>
+      </p:nvGrpSpPr>
+      <p:grpSpPr/>
+      <p:sp>
+        <p:nvSpPr>
+          <p:cNvPr id="2" name="TextBox 1"/>
+          <p:cNvSpPr txBox="1"/>
+          <p:nvPr/>
+        </p:nvSpPr>
+        <p:spPr>
+          <a:xfrm>
+            <a:off x="548640" y="384048"/>
+            <a:ext cx="11064240" cy="731520"/>
+          </a:xfrm>
+          <a:prstGeom prst="rect">
+            <a:avLst/>
+          </a:prstGeom>
+          <a:noFill/>
+        </p:spPr>
+        <p:txBody>
+          <a:bodyPr wrap="square" anchor="t" lIns="0" rIns="0" tIns="0" bIns="0">
+            <a:spAutoFit/>
+          </a:bodyPr>
+          <a:lstStyle/>
+          <a:p>
+            <a:pPr algn="l">
+              <a:lnSpc>
+                <a:spcPct val="105000"/>
+              </a:lnSpc>
+              <a:spcBef>
+                <a:spcPts val="0"/>
+              </a:spcBef>
+              <a:spcAft>
+                <a:spcPts val="400"/>
+              </a:spcAft>
+            </a:pPr>
+            <a:r>
+              <a:rPr sz="2800" b="1">
+                <a:solidFill>
+                  <a:srgbClr val="162A4A"/>
+                </a:solidFill>
+                <a:latin typeface="Cambria"/>
+              </a:rPr>
+              <a:t>Benchmark structures and their quotients  (2 / 3)</a:t>
+            </a:r>
+          </a:p>
+        </p:txBody>
+      </p:sp>
+      <p:sp>
+        <p:nvSpPr>
+          <p:cNvPr id="3" name="TextBox 2"/>
+          <p:cNvSpPr txBox="1"/>
+          <p:nvPr/>
+        </p:nvSpPr>
+        <p:spPr>
+          <a:xfrm>
+            <a:off x="502920" y="1371600"/>
+            <a:ext cx="2331720" cy="2583180"/>
+          </a:xfrm>
+          <a:prstGeom prst="rect">
+            <a:avLst/>
+          </a:prstGeom>
+          <a:noFill/>
+        </p:spPr>
+        <p:txBody>
+          <a:bodyPr wrap="square" anchor="ctr" lIns="0" rIns="0" tIns="0" bIns="0">
+            <a:spAutoFit/>
+          </a:bodyPr>
+          <a:lstStyle/>
+          <a:p>
+            <a:pPr algn="l">
+              <a:lnSpc>
+                <a:spcPct val="105000"/>
+              </a:lnSpc>
+              <a:spcBef>
+                <a:spcPts val="0"/>
+              </a:spcBef>
+              <a:spcAft>
+                <a:spcPts val="300"/>
+              </a:spcAft>
+            </a:pPr>
+            <a:r>
+              <a:rPr sz="1700" b="1">
+                <a:solidFill>
+                  <a:srgbClr val="162A4A"/>
+                </a:solidFill>
+                <a:latin typeface="Calibri"/>
+              </a:rPr>
+              <a:t>Epidemiology</a:t>
+            </a:r>
+          </a:p>
+          <a:p>
+            <a:pPr algn="l">
+              <a:lnSpc>
+                <a:spcPct val="105000"/>
+              </a:lnSpc>
+              <a:spcBef>
+                <a:spcPts val="0"/>
+              </a:spcBef>
+              <a:spcAft>
+                <a:spcPts val="300"/>
+              </a:spcAft>
+            </a:pPr>
+            <a:r>
+              <a:rPr sz="1200" b="0">
+                <a:solidFill>
+                  <a:srgbClr val="5B6B7B"/>
+                </a:solidFill>
+                <a:latin typeface="Calibri"/>
+              </a:rPr>
+              <a:t>cluster {L, B}</a:t>
+            </a:r>
+          </a:p>
+        </p:txBody>
+      </p:sp>
+      <p:pic>
+        <p:nvPicPr>
+          <p:cNvPr id="4" name="Picture 3" descr="Epidemiology_dag.png"/>
+          <p:cNvPicPr>
+            <a:picLocks noChangeAspect="1"/>
+          </p:cNvPicPr>
+          <p:nvPr/>
+        </p:nvPicPr>
+        <p:blipFill>
+          <a:blip r:embed="rId2"/>
+          <a:stretch>
+            <a:fillRect/>
+          </a:stretch>
+        </p:blipFill>
+        <p:spPr>
+          <a:xfrm>
+            <a:off x="3753662" y="1463040"/>
+            <a:ext cx="1453794" cy="2272284"/>
+          </a:xfrm>
+          <a:prstGeom prst="rect">
+            <a:avLst/>
+          </a:prstGeom>
+        </p:spPr>
+      </p:pic>
+      <p:sp>
+        <p:nvSpPr>
+          <p:cNvPr id="5" name="TextBox 4"/>
+          <p:cNvSpPr txBox="1"/>
+          <p:nvPr/>
+        </p:nvSpPr>
+        <p:spPr>
+          <a:xfrm>
+            <a:off x="6126480" y="1371600"/>
+            <a:ext cx="640080" cy="2583180"/>
+          </a:xfrm>
+          <a:prstGeom prst="rect">
+            <a:avLst/>
+          </a:prstGeom>
+          <a:noFill/>
+        </p:spPr>
+        <p:txBody>
+          <a:bodyPr wrap="square" anchor="ctr" lIns="0" rIns="0" tIns="0" bIns="0">
+            <a:spAutoFit/>
+          </a:bodyPr>
+          <a:lstStyle/>
+          <a:p>
+            <a:pPr algn="ctr">
+              <a:lnSpc>
+                <a:spcPct val="105000"/>
+              </a:lnSpc>
+              <a:spcBef>
+                <a:spcPts val="0"/>
+              </a:spcBef>
+              <a:spcAft>
+                <a:spcPts val="400"/>
+              </a:spcAft>
+            </a:pPr>
+            <a:r>
+              <a:rPr sz="2600" b="1">
+                <a:solidFill>
+                  <a:srgbClr val="0E8388"/>
+                </a:solidFill>
+                <a:latin typeface="Calibri"/>
+              </a:rPr>
+              <a:t>→</a:t>
+            </a:r>
+          </a:p>
+        </p:txBody>
+      </p:sp>
+      <p:pic>
+        <p:nvPicPr>
+          <p:cNvPr id="6" name="Picture 5" descr="Epidemiology_cdag.png"/>
+          <p:cNvPicPr>
+            <a:picLocks noChangeAspect="1"/>
+          </p:cNvPicPr>
+          <p:nvPr/>
+        </p:nvPicPr>
+        <p:blipFill>
+          <a:blip r:embed="rId3"/>
+          <a:stretch>
+            <a:fillRect/>
+          </a:stretch>
+        </p:blipFill>
+        <p:spPr>
+          <a:xfrm>
+            <a:off x="7905719" y="1463040"/>
+            <a:ext cx="1104961" cy="2272284"/>
+          </a:xfrm>
+          <a:prstGeom prst="rect">
+            <a:avLst/>
+          </a:prstGeom>
+        </p:spPr>
+      </p:pic>
+      <p:sp>
+        <p:nvSpPr>
+          <p:cNvPr id="7" name="TextBox 6"/>
+          <p:cNvSpPr txBox="1"/>
+          <p:nvPr/>
+        </p:nvSpPr>
+        <p:spPr>
+          <a:xfrm>
+            <a:off x="502920" y="3954780"/>
+            <a:ext cx="2331720" cy="2583180"/>
+          </a:xfrm>
+          <a:prstGeom prst="rect">
+            <a:avLst/>
+          </a:prstGeom>
+          <a:noFill/>
+        </p:spPr>
+        <p:txBody>
+          <a:bodyPr wrap="square" anchor="ctr" lIns="0" rIns="0" tIns="0" bIns="0">
+            <a:spAutoFit/>
+          </a:bodyPr>
+          <a:lstStyle/>
+          <a:p>
+            <a:pPr algn="l">
+              <a:lnSpc>
+                <a:spcPct val="105000"/>
+              </a:lnSpc>
+              <a:spcBef>
+                <a:spcPts val="0"/>
+              </a:spcBef>
+              <a:spcAft>
+                <a:spcPts val="300"/>
+              </a:spcAft>
+            </a:pPr>
+            <a:r>
+              <a:rPr sz="1700" b="1">
+                <a:solidFill>
+                  <a:srgbClr val="162A4A"/>
+                </a:solidFill>
+                <a:latin typeface="Calibri"/>
+              </a:rPr>
+              <a:t>Healthcare</a:t>
+            </a:r>
+          </a:p>
+          <a:p>
+            <a:pPr algn="l">
+              <a:lnSpc>
+                <a:spcPct val="105000"/>
+              </a:lnSpc>
+              <a:spcBef>
+                <a:spcPts val="0"/>
+              </a:spcBef>
+              <a:spcAft>
+                <a:spcPts val="300"/>
+              </a:spcAft>
+            </a:pPr>
+            <a:r>
+              <a:rPr sz="1200" b="0">
+                <a:solidFill>
+                  <a:srgbClr val="5B6B7B"/>
+                </a:solidFill>
+                <a:latin typeface="Calibri"/>
+              </a:rPr>
+              <a:t>cluster {Aspirin, Statin}</a:t>
+            </a:r>
+          </a:p>
+        </p:txBody>
+      </p:sp>
+      <p:pic>
+        <p:nvPicPr>
+          <p:cNvPr id="8" name="Picture 7" descr="Healthcare_dag.png"/>
+          <p:cNvPicPr>
+            <a:picLocks noChangeAspect="1"/>
+          </p:cNvPicPr>
+          <p:nvPr/>
+        </p:nvPicPr>
+        <p:blipFill>
+          <a:blip r:embed="rId4"/>
+          <a:stretch>
+            <a:fillRect/>
+          </a:stretch>
+        </p:blipFill>
+        <p:spPr>
+          <a:xfrm>
+            <a:off x="3893605" y="4046220"/>
+            <a:ext cx="1173908" cy="2272284"/>
+          </a:xfrm>
+          <a:prstGeom prst="rect">
+            <a:avLst/>
+          </a:prstGeom>
+        </p:spPr>
+      </p:pic>
+      <p:sp>
+        <p:nvSpPr>
+          <p:cNvPr id="9" name="TextBox 8"/>
+          <p:cNvSpPr txBox="1"/>
+          <p:nvPr/>
+        </p:nvSpPr>
+        <p:spPr>
+          <a:xfrm>
+            <a:off x="6126480" y="3954780"/>
+            <a:ext cx="640080" cy="2583180"/>
+          </a:xfrm>
+          <a:prstGeom prst="rect">
+            <a:avLst/>
+          </a:prstGeom>
+          <a:noFill/>
+        </p:spPr>
+        <p:txBody>
+          <a:bodyPr wrap="square" anchor="ctr" lIns="0" rIns="0" tIns="0" bIns="0">
+            <a:spAutoFit/>
+          </a:bodyPr>
+          <a:lstStyle/>
+          <a:p>
+            <a:pPr algn="ctr">
+              <a:lnSpc>
+                <a:spcPct val="105000"/>
+              </a:lnSpc>
+              <a:spcBef>
+                <a:spcPts val="0"/>
+              </a:spcBef>
+              <a:spcAft>
+                <a:spcPts val="400"/>
+              </a:spcAft>
+            </a:pPr>
+            <a:r>
+              <a:rPr sz="2600" b="1">
+                <a:solidFill>
+                  <a:srgbClr val="0E8388"/>
+                </a:solidFill>
+                <a:latin typeface="Calibri"/>
+              </a:rPr>
+              <a:t>→</a:t>
+            </a:r>
+          </a:p>
+        </p:txBody>
+      </p:sp>
+      <p:pic>
+        <p:nvPicPr>
+          <p:cNvPr id="10" name="Picture 9" descr="Healthcare_cdag.png"/>
+          <p:cNvPicPr>
+            <a:picLocks noChangeAspect="1"/>
+          </p:cNvPicPr>
+          <p:nvPr/>
+        </p:nvPicPr>
+        <p:blipFill>
+          <a:blip r:embed="rId5"/>
+          <a:stretch>
+            <a:fillRect/>
+          </a:stretch>
+        </p:blipFill>
+        <p:spPr>
+          <a:xfrm>
+            <a:off x="8012083" y="4046220"/>
+            <a:ext cx="892233" cy="2272284"/>
+          </a:xfrm>
+          <a:prstGeom prst="rect">
+            <a:avLst/>
+          </a:prstGeom>
+        </p:spPr>
+      </p:pic>
+      <p:sp>
+        <p:nvSpPr>
+          <p:cNvPr id="11" name="TextBox 10"/>
+          <p:cNvSpPr txBox="1"/>
+          <p:nvPr/>
+        </p:nvSpPr>
+        <p:spPr>
+          <a:xfrm>
+            <a:off x="548640" y="6510528"/>
+            <a:ext cx="11064240" cy="292608"/>
+          </a:xfrm>
+          <a:prstGeom prst="rect">
+            <a:avLst/>
+          </a:prstGeom>
+          <a:noFill/>
+        </p:spPr>
+        <p:txBody>
+          <a:bodyPr wrap="square" anchor="t" lIns="0" rIns="0" tIns="0" bIns="0">
+            <a:spAutoFit/>
+          </a:bodyPr>
+          <a:lstStyle/>
+          <a:p>
+            <a:pPr algn="ctr">
+              <a:lnSpc>
+                <a:spcPct val="105000"/>
+              </a:lnSpc>
+              <a:spcBef>
+                <a:spcPts val="0"/>
+              </a:spcBef>
+              <a:spcAft>
+                <a:spcPts val="400"/>
+              </a:spcAft>
+            </a:pPr>
+            <a:r>
+              <a:rPr sz="1100" b="0" i="1">
+                <a:solidFill>
+                  <a:srgbClr val="5B6B7B"/>
+                </a:solidFill>
+                <a:latin typeface="Calibri"/>
+              </a:rPr>
+              <a:t>fine DAG  →  quotient C-DAG   (orange = manipulable, box = cluster, dashed red = latent confounder)</a:t>
+            </a:r>
+          </a:p>
+        </p:txBody>
+      </p:sp>
+    </p:spTree>
+  </p:cSld>
+  <p:clrMapOvr>
+    <a:masterClrMapping/>
+  </p:clrMapOvr>
+</p:sld>
+</file>
+
+<file path=ppt/slides/slide6.xml><?xml version="1.0" encoding="utf-8"?>
+<p:sld xmlns:a="http://schemas.openxmlformats.org/drawingml/2006/main" xmlns:p="http://schemas.openxmlformats.org/presentationml/2006/main" xmlns:r="http://schemas.openxmlformats.org/officeDocument/2006/relationships">
+  <p:cSld>
+    <p:bg>
+      <p:bgPr>
+        <a:solidFill>
+          <a:srgbClr val="FFFFFF"/>
+        </a:solidFill>
+        <a:effectLst/>
+      </p:bgPr>
+    </p:bg>
+    <p:spTree>
+      <p:nvGrpSpPr>
+        <p:cNvPr id="1" name=""/>
+        <p:cNvGrpSpPr/>
+        <p:nvPr/>
+      </p:nvGrpSpPr>
+      <p:grpSpPr/>
+      <p:sp>
+        <p:nvSpPr>
+          <p:cNvPr id="2" name="TextBox 1"/>
+          <p:cNvSpPr txBox="1"/>
+          <p:nvPr/>
+        </p:nvSpPr>
+        <p:spPr>
+          <a:xfrm>
+            <a:off x="548640" y="384048"/>
+            <a:ext cx="11064240" cy="731520"/>
+          </a:xfrm>
+          <a:prstGeom prst="rect">
+            <a:avLst/>
+          </a:prstGeom>
+          <a:noFill/>
+        </p:spPr>
+        <p:txBody>
+          <a:bodyPr wrap="square" anchor="t" lIns="0" rIns="0" tIns="0" bIns="0">
+            <a:spAutoFit/>
+          </a:bodyPr>
+          <a:lstStyle/>
+          <a:p>
+            <a:pPr algn="l">
+              <a:lnSpc>
+                <a:spcPct val="105000"/>
+              </a:lnSpc>
+              <a:spcBef>
+                <a:spcPts val="0"/>
+              </a:spcBef>
+              <a:spcAft>
+                <a:spcPts val="400"/>
+              </a:spcAft>
+            </a:pPr>
+            <a:r>
+              <a:rPr sz="2800" b="1">
+                <a:solidFill>
+                  <a:srgbClr val="162A4A"/>
+                </a:solidFill>
+                <a:latin typeface="Cambria"/>
+              </a:rPr>
+              <a:t>Benchmark structures and their quotients  (3 / 3)</a:t>
+            </a:r>
+          </a:p>
+        </p:txBody>
+      </p:sp>
+      <p:sp>
+        <p:nvSpPr>
+          <p:cNvPr id="3" name="TextBox 2"/>
+          <p:cNvSpPr txBox="1"/>
+          <p:nvPr/>
+        </p:nvSpPr>
+        <p:spPr>
+          <a:xfrm>
+            <a:off x="502920" y="1371600"/>
+            <a:ext cx="2331720" cy="2583180"/>
+          </a:xfrm>
+          <a:prstGeom prst="rect">
+            <a:avLst/>
+          </a:prstGeom>
+          <a:noFill/>
+        </p:spPr>
+        <p:txBody>
+          <a:bodyPr wrap="square" anchor="ctr" lIns="0" rIns="0" tIns="0" bIns="0">
+            <a:spAutoFit/>
+          </a:bodyPr>
+          <a:lstStyle/>
+          <a:p>
+            <a:pPr algn="l">
+              <a:lnSpc>
+                <a:spcPct val="105000"/>
+              </a:lnSpc>
+              <a:spcBef>
+                <a:spcPts val="0"/>
+              </a:spcBef>
+              <a:spcAft>
+                <a:spcPts val="300"/>
+              </a:spcAft>
+            </a:pPr>
+            <a:r>
+              <a:rPr sz="1700" b="1">
+                <a:solidFill>
+                  <a:srgbClr val="162A4A"/>
+                </a:solidFill>
+                <a:latin typeface="Calibri"/>
+              </a:rPr>
+              <a:t>Ecology</a:t>
+            </a:r>
+          </a:p>
+          <a:p>
+            <a:pPr algn="l">
+              <a:lnSpc>
+                <a:spcPct val="105000"/>
+              </a:lnSpc>
+              <a:spcBef>
+                <a:spcPts val="0"/>
+              </a:spcBef>
+              <a:spcAft>
+                <a:spcPts val="300"/>
+              </a:spcAft>
+            </a:pPr>
+            <a:r>
+              <a:rPr sz="1200" b="0">
+                <a:solidFill>
+                  <a:srgbClr val="5B6B7B"/>
+                </a:solidFill>
+                <a:latin typeface="Calibri"/>
+              </a:rPr>
+              <a:t>clusters {C,N,O}, {D,T}</a:t>
+            </a:r>
+          </a:p>
+        </p:txBody>
+      </p:sp>
+      <p:pic>
+        <p:nvPicPr>
+          <p:cNvPr id="4" name="Picture 3" descr="Ecology_dag.png"/>
+          <p:cNvPicPr>
+            <a:picLocks noChangeAspect="1"/>
+          </p:cNvPicPr>
+          <p:nvPr/>
+        </p:nvPicPr>
+        <p:blipFill>
+          <a:blip r:embed="rId2"/>
+          <a:stretch>
+            <a:fillRect/>
+          </a:stretch>
+        </p:blipFill>
+        <p:spPr>
+          <a:xfrm>
+            <a:off x="3064767" y="1463040"/>
+            <a:ext cx="2831585" cy="2272284"/>
+          </a:xfrm>
+          <a:prstGeom prst="rect">
+            <a:avLst/>
+          </a:prstGeom>
+        </p:spPr>
+      </p:pic>
+      <p:sp>
+        <p:nvSpPr>
+          <p:cNvPr id="5" name="TextBox 4"/>
+          <p:cNvSpPr txBox="1"/>
+          <p:nvPr/>
+        </p:nvSpPr>
+        <p:spPr>
+          <a:xfrm>
+            <a:off x="6126480" y="1371600"/>
+            <a:ext cx="640080" cy="2583180"/>
+          </a:xfrm>
+          <a:prstGeom prst="rect">
+            <a:avLst/>
+          </a:prstGeom>
+          <a:noFill/>
+        </p:spPr>
+        <p:txBody>
+          <a:bodyPr wrap="square" anchor="ctr" lIns="0" rIns="0" tIns="0" bIns="0">
+            <a:spAutoFit/>
+          </a:bodyPr>
+          <a:lstStyle/>
+          <a:p>
+            <a:pPr algn="ctr">
+              <a:lnSpc>
+                <a:spcPct val="105000"/>
+              </a:lnSpc>
+              <a:spcBef>
+                <a:spcPts val="0"/>
+              </a:spcBef>
+              <a:spcAft>
+                <a:spcPts val="400"/>
+              </a:spcAft>
+            </a:pPr>
+            <a:r>
+              <a:rPr sz="2600" b="1">
+                <a:solidFill>
+                  <a:srgbClr val="0E8388"/>
+                </a:solidFill>
+                <a:latin typeface="Calibri"/>
+              </a:rPr>
+              <a:t>→</a:t>
+            </a:r>
+          </a:p>
+        </p:txBody>
+      </p:sp>
+      <p:pic>
+        <p:nvPicPr>
+          <p:cNvPr id="6" name="Picture 5" descr="Ecology_cdag.png"/>
+          <p:cNvPicPr>
+            <a:picLocks noChangeAspect="1"/>
+          </p:cNvPicPr>
+          <p:nvPr/>
+        </p:nvPicPr>
+        <p:blipFill>
+          <a:blip r:embed="rId3"/>
+          <a:stretch>
+            <a:fillRect/>
+          </a:stretch>
+        </p:blipFill>
+        <p:spPr>
+          <a:xfrm>
+            <a:off x="7592717" y="1463040"/>
+            <a:ext cx="1730964" cy="2272284"/>
+          </a:xfrm>
+          <a:prstGeom prst="rect">
+            <a:avLst/>
+          </a:prstGeom>
+        </p:spPr>
+      </p:pic>
+      <p:sp>
+        <p:nvSpPr>
+          <p:cNvPr id="7" name="TextBox 6"/>
+          <p:cNvSpPr txBox="1"/>
+          <p:nvPr/>
+        </p:nvSpPr>
+        <p:spPr>
+          <a:xfrm>
+            <a:off x="502920" y="3954780"/>
+            <a:ext cx="2331720" cy="2583180"/>
+          </a:xfrm>
+          <a:prstGeom prst="rect">
+            <a:avLst/>
+          </a:prstGeom>
+          <a:noFill/>
+        </p:spPr>
+        <p:txBody>
+          <a:bodyPr wrap="square" anchor="ctr" lIns="0" rIns="0" tIns="0" bIns="0">
+            <a:spAutoFit/>
+          </a:bodyPr>
+          <a:lstStyle/>
+          <a:p>
+            <a:pPr algn="l">
+              <a:lnSpc>
+                <a:spcPct val="105000"/>
+              </a:lnSpc>
+              <a:spcBef>
+                <a:spcPts val="0"/>
+              </a:spcBef>
+              <a:spcAft>
+                <a:spcPts val="300"/>
+              </a:spcAft>
+            </a:pPr>
+            <a:r>
+              <a:rPr sz="1700" b="1">
+                <a:solidFill>
+                  <a:srgbClr val="162A4A"/>
+                </a:solidFill>
+                <a:latin typeface="Calibri"/>
+              </a:rPr>
+              <a:t>Protein</a:t>
+            </a:r>
+          </a:p>
+          <a:p>
+            <a:pPr algn="l">
+              <a:lnSpc>
+                <a:spcPct val="105000"/>
+              </a:lnSpc>
+              <a:spcBef>
+                <a:spcPts val="0"/>
+              </a:spcBef>
+              <a:spcAft>
+                <a:spcPts val="300"/>
+              </a:spcAft>
+            </a:pPr>
+            <a:r>
+              <a:rPr sz="1200" b="0">
+                <a:solidFill>
+                  <a:srgbClr val="5B6B7B"/>
+                </a:solidFill>
+                <a:latin typeface="Calibri"/>
+              </a:rPr>
+              <a:t>clusters {Akt,Mek}, {PKA,PKC}</a:t>
+            </a:r>
+          </a:p>
+        </p:txBody>
+      </p:sp>
+      <p:pic>
+        <p:nvPicPr>
+          <p:cNvPr id="8" name="Picture 7" descr="Protein_dag.png"/>
+          <p:cNvPicPr>
+            <a:picLocks noChangeAspect="1"/>
+          </p:cNvPicPr>
+          <p:nvPr/>
+        </p:nvPicPr>
+        <p:blipFill>
+          <a:blip r:embed="rId4"/>
+          <a:stretch>
+            <a:fillRect/>
+          </a:stretch>
+        </p:blipFill>
+        <p:spPr>
+          <a:xfrm>
+            <a:off x="3337336" y="4046220"/>
+            <a:ext cx="2286446" cy="2272284"/>
+          </a:xfrm>
+          <a:prstGeom prst="rect">
+            <a:avLst/>
+          </a:prstGeom>
+        </p:spPr>
+      </p:pic>
+      <p:sp>
+        <p:nvSpPr>
+          <p:cNvPr id="9" name="TextBox 8"/>
+          <p:cNvSpPr txBox="1"/>
+          <p:nvPr/>
+        </p:nvSpPr>
+        <p:spPr>
+          <a:xfrm>
+            <a:off x="6126480" y="3954780"/>
+            <a:ext cx="640080" cy="2583180"/>
+          </a:xfrm>
+          <a:prstGeom prst="rect">
+            <a:avLst/>
+          </a:prstGeom>
+          <a:noFill/>
+        </p:spPr>
+        <p:txBody>
+          <a:bodyPr wrap="square" anchor="ctr" lIns="0" rIns="0" tIns="0" bIns="0">
+            <a:spAutoFit/>
+          </a:bodyPr>
+          <a:lstStyle/>
+          <a:p>
+            <a:pPr algn="ctr">
+              <a:lnSpc>
+                <a:spcPct val="105000"/>
+              </a:lnSpc>
+              <a:spcBef>
+                <a:spcPts val="0"/>
+              </a:spcBef>
+              <a:spcAft>
+                <a:spcPts val="400"/>
+              </a:spcAft>
+            </a:pPr>
+            <a:r>
+              <a:rPr sz="2600" b="1">
+                <a:solidFill>
+                  <a:srgbClr val="0E8388"/>
+                </a:solidFill>
+                <a:latin typeface="Calibri"/>
+              </a:rPr>
+              <a:t>→</a:t>
+            </a:r>
+          </a:p>
+        </p:txBody>
+      </p:sp>
+      <p:pic>
+        <p:nvPicPr>
+          <p:cNvPr id="10" name="Picture 9" descr="Protein_cdag.png"/>
+          <p:cNvPicPr>
+            <a:picLocks noChangeAspect="1"/>
+          </p:cNvPicPr>
+          <p:nvPr/>
+        </p:nvPicPr>
+        <p:blipFill>
+          <a:blip r:embed="rId5"/>
+          <a:stretch>
+            <a:fillRect/>
+          </a:stretch>
+        </p:blipFill>
+        <p:spPr>
+          <a:xfrm>
+            <a:off x="7386367" y="4046220"/>
+            <a:ext cx="2143664" cy="2272284"/>
+          </a:xfrm>
+          <a:prstGeom prst="rect">
+            <a:avLst/>
+          </a:prstGeom>
+        </p:spPr>
+      </p:pic>
+      <p:sp>
+        <p:nvSpPr>
+          <p:cNvPr id="11" name="TextBox 10"/>
+          <p:cNvSpPr txBox="1"/>
+          <p:nvPr/>
+        </p:nvSpPr>
+        <p:spPr>
+          <a:xfrm>
+            <a:off x="548640" y="6510528"/>
+            <a:ext cx="11064240" cy="292608"/>
+          </a:xfrm>
+          <a:prstGeom prst="rect">
+            <a:avLst/>
+          </a:prstGeom>
+          <a:noFill/>
+        </p:spPr>
+        <p:txBody>
+          <a:bodyPr wrap="square" anchor="t" lIns="0" rIns="0" tIns="0" bIns="0">
+            <a:spAutoFit/>
+          </a:bodyPr>
+          <a:lstStyle/>
+          <a:p>
+            <a:pPr algn="ctr">
+              <a:lnSpc>
+                <a:spcPct val="105000"/>
+              </a:lnSpc>
+              <a:spcBef>
+                <a:spcPts val="0"/>
+              </a:spcBef>
+              <a:spcAft>
+                <a:spcPts val="400"/>
+              </a:spcAft>
+            </a:pPr>
+            <a:r>
+              <a:rPr sz="1100" b="0" i="1">
+                <a:solidFill>
+                  <a:srgbClr val="5B6B7B"/>
+                </a:solidFill>
+                <a:latin typeface="Calibri"/>
+              </a:rPr>
+              <a:t>fine DAG  →  quotient C-DAG   (orange = manipulable, box = cluster, dashed red = latent confounder)</a:t>
             </a:r>
           </a:p>
         </p:txBody>

</xml_diff>

<commit_message>
Slides: misspec-headline and field/CEO slides, data-driven from the study JSON
Two new slides in the explainer deck, built from
results/clusterbench10_misspec.json at build time: (1) the invariance
headline -- dGAP@100 per perturbation as a native bar chart, QCBO-coarse's
exact zeros vs finest's shifts, with the two-channel damage taxonomy; (2)
the field comparison -- BO / CBO / CEO / QCBO-coarse cards; the CEO card and
a CEO chart series auto-fill once the misspec sweep merges into the JSON.

Co-Authored-By: Claude Fable 5 <noreply@anthropic.com>
</commit_message>
<xml_diff>
--- a/slides/GAP_PA-GAP_explainer.pptx
+++ b/slides/GAP_PA-GAP_explainer.pptx
@@ -12,6 +12,8 @@
     <p:sldId id="260" r:id="rId11"/>
     <p:sldId id="261" r:id="rId12"/>
     <p:sldId id="262" r:id="rId13"/>
+    <p:sldId id="263" r:id="rId15"/>
+    <p:sldId id="264" r:id="rId16"/>
   </p:sldIdLst>
   <p:sldSz cx="12191695" cy="6858000" type="screen4x3"/>
   <p:notesSz cx="6858000" cy="9144000"/>
@@ -576,6 +578,297 @@
 </c:chartSpace>
 </file>
 
+<file path=ppt/charts/chart3.xml><?xml version="1.0" encoding="utf-8"?>
+<c:chartSpace xmlns:c="http://schemas.openxmlformats.org/drawingml/2006/chart" xmlns:a="http://schemas.openxmlformats.org/drawingml/2006/main" xmlns:r="http://schemas.openxmlformats.org/officeDocument/2006/relationships">
+  <c:date1904 val="0"/>
+  <c:chart>
+    <c:autoTitleDeleted val="1"/>
+    <c:plotArea>
+      <c:barChart>
+        <c:barDir val="bar"/>
+        <c:grouping val="clustered"/>
+        <c:ser>
+          <c:idx val="0"/>
+          <c:order val="0"/>
+          <c:tx>
+            <c:strRef>
+              <c:f>Sheet1!$B$1</c:f>
+              <c:strCache>
+                <c:ptCount val="1"/>
+                <c:pt idx="0">
+                  <c:v>QCBO-finest</c:v>
+                </c:pt>
+              </c:strCache>
+            </c:strRef>
+          </c:tx>
+          <c:spPr>
+            <a:solidFill>
+              <a:srgbClr val="E69F00"/>
+            </a:solidFill>
+          </c:spPr>
+          <c:cat>
+            <c:strRef>
+              <c:f>Sheet1!$A$2:$A$10</c:f>
+              <c:strCache>
+                <c:ptCount val="9"/>
+                <c:pt idx="0">
+                  <c:v>add X1→X2 (bow)</c:v>
+                </c:pt>
+                <c:pt idx="1">
+                  <c:v>del X3→X2</c:v>
+                </c:pt>
+                <c:pt idx="2">
+                  <c:v>rev X3→X2</c:v>
+                </c:pt>
+                <c:pt idx="3">
+                  <c:v>omit X1↔X2 conf.</c:v>
+                </c:pt>
+                <c:pt idx="4">
+                  <c:v>sweep k=2</c:v>
+                </c:pt>
+                <c:pt idx="5">
+                  <c:v>sweep k=3</c:v>
+                </c:pt>
+                <c:pt idx="6">
+                  <c:v>del X1→M2 (red.)</c:v>
+                </c:pt>
+                <c:pt idx="7">
+                  <c:v>del X3→M1</c:v>
+                </c:pt>
+                <c:pt idx="8">
+                  <c:v>inter bow X1→X5</c:v>
+                </c:pt>
+              </c:strCache>
+            </c:strRef>
+          </c:cat>
+          <c:val>
+            <c:numRef>
+              <c:f>Sheet1!$B$2:$B$10</c:f>
+              <c:numCache>
+                <c:formatCode>General</c:formatCode>
+                <c:ptCount val="9"/>
+                <c:pt idx="0">
+                  <c:v>0.1162893386616998</c:v>
+                </c:pt>
+                <c:pt idx="1">
+                  <c:v>0.1559334876977081</c:v>
+                </c:pt>
+                <c:pt idx="2">
+                  <c:v>0.1559334876977081</c:v>
+                </c:pt>
+                <c:pt idx="3">
+                  <c:v>0.09817484963833784</c:v>
+                </c:pt>
+                <c:pt idx="4">
+                  <c:v>0.11976963386448973</c:v>
+                </c:pt>
+                <c:pt idx="5">
+                  <c:v>0.11973384953189788</c:v>
+                </c:pt>
+                <c:pt idx="6">
+                  <c:v>0.12180890207211796</c:v>
+                </c:pt>
+                <c:pt idx="7">
+                  <c:v>0.040298531185743794</c:v>
+                </c:pt>
+                <c:pt idx="8">
+                  <c:v>0.0066563174673977595</c:v>
+                </c:pt>
+              </c:numCache>
+            </c:numRef>
+          </c:val>
+        </c:ser>
+        <c:ser>
+          <c:idx val="1"/>
+          <c:order val="1"/>
+          <c:tx>
+            <c:strRef>
+              <c:f>Sheet1!$C$1</c:f>
+              <c:strCache>
+                <c:ptCount val="1"/>
+                <c:pt idx="0">
+                  <c:v>QCBO-coarse</c:v>
+                </c:pt>
+              </c:strCache>
+            </c:strRef>
+          </c:tx>
+          <c:spPr>
+            <a:solidFill>
+              <a:srgbClr val="D55E00"/>
+            </a:solidFill>
+          </c:spPr>
+          <c:cat>
+            <c:strRef>
+              <c:f>Sheet1!$A$2:$A$10</c:f>
+              <c:strCache>
+                <c:ptCount val="9"/>
+                <c:pt idx="0">
+                  <c:v>add X1→X2 (bow)</c:v>
+                </c:pt>
+                <c:pt idx="1">
+                  <c:v>del X3→X2</c:v>
+                </c:pt>
+                <c:pt idx="2">
+                  <c:v>rev X3→X2</c:v>
+                </c:pt>
+                <c:pt idx="3">
+                  <c:v>omit X1↔X2 conf.</c:v>
+                </c:pt>
+                <c:pt idx="4">
+                  <c:v>sweep k=2</c:v>
+                </c:pt>
+                <c:pt idx="5">
+                  <c:v>sweep k=3</c:v>
+                </c:pt>
+                <c:pt idx="6">
+                  <c:v>del X1→M2 (red.)</c:v>
+                </c:pt>
+                <c:pt idx="7">
+                  <c:v>del X3→M1</c:v>
+                </c:pt>
+                <c:pt idx="8">
+                  <c:v>inter bow X1→X5</c:v>
+                </c:pt>
+              </c:strCache>
+            </c:strRef>
+          </c:cat>
+          <c:val>
+            <c:numRef>
+              <c:f>Sheet1!$C$2:$C$10</c:f>
+              <c:numCache>
+                <c:formatCode>General</c:formatCode>
+                <c:ptCount val="9"/>
+                <c:pt idx="0">
+                  <c:v>0.0</c:v>
+                </c:pt>
+                <c:pt idx="1">
+                  <c:v>0.0</c:v>
+                </c:pt>
+                <c:pt idx="2">
+                  <c:v>0.0</c:v>
+                </c:pt>
+                <c:pt idx="3">
+                  <c:v>0.0</c:v>
+                </c:pt>
+                <c:pt idx="4">
+                  <c:v>0.0</c:v>
+                </c:pt>
+                <c:pt idx="5">
+                  <c:v>0.0</c:v>
+                </c:pt>
+                <c:pt idx="6">
+                  <c:v>0.0</c:v>
+                </c:pt>
+                <c:pt idx="7">
+                  <c:v>0.0</c:v>
+                </c:pt>
+                <c:pt idx="8">
+                  <c:v>-0.006606812812277707</c:v>
+                </c:pt>
+              </c:numCache>
+            </c:numRef>
+          </c:val>
+        </c:ser>
+        <c:axId val="-2068027336"/>
+        <c:axId val="-2113994440"/>
+      </c:barChart>
+      <c:catAx>
+        <c:axId val="-2068027336"/>
+        <c:scaling>
+          <c:orientation val="minMax"/>
+        </c:scaling>
+        <c:delete val="0"/>
+        <c:axPos val="l"/>
+        <c:majorTickMark val="out"/>
+        <c:minorTickMark val="none"/>
+        <c:tickLblPos val="low"/>
+        <c:txPr>
+          <a:bodyPr/>
+          <a:lstStyle/>
+          <a:p>
+            <a:pPr>
+              <a:defRPr sz="1000">
+                <a:solidFill>
+                  <a:srgbClr val="243242"/>
+                </a:solidFill>
+              </a:defRPr>
+            </a:pPr>
+          </a:p>
+        </c:txPr>
+        <c:crossAx val="-2113994440"/>
+        <c:crosses val="autoZero"/>
+        <c:auto val="1"/>
+        <c:lblAlgn val="ctr"/>
+        <c:lblOffset val="100"/>
+        <c:noMultiLvlLbl val="0"/>
+      </c:catAx>
+      <c:valAx>
+        <c:axId val="-2113994440"/>
+        <c:scaling/>
+        <c:delete val="0"/>
+        <c:axPos val="b"/>
+        <c:majorGridlines>
+          <c:spPr>
+            <a:ln w="6350">
+              <a:solidFill>
+                <a:srgbClr val="E6EAEE"/>
+              </a:solidFill>
+            </a:ln>
+          </c:spPr>
+        </c:majorGridlines>
+        <c:majorTickMark val="out"/>
+        <c:minorTickMark val="none"/>
+        <c:tickLblPos val="nextTo"/>
+        <c:txPr>
+          <a:bodyPr/>
+          <a:lstStyle/>
+          <a:p>
+            <a:pPr>
+              <a:defRPr sz="950">
+                <a:solidFill>
+                  <a:srgbClr val="5B6B7B"/>
+                </a:solidFill>
+              </a:defRPr>
+            </a:pPr>
+          </a:p>
+        </c:txPr>
+        <c:crossAx val="-2068027336"/>
+        <c:crosses val="autoZero"/>
+      </c:valAx>
+    </c:plotArea>
+    <c:legend>
+      <c:legendPos val="tr"/>
+      <c:overlay val="0"/>
+      <c:txPr>
+        <a:bodyPr/>
+        <a:lstStyle/>
+        <a:p>
+          <a:pPr>
+            <a:defRPr sz="1100">
+              <a:latin typeface="Calibri"/>
+            </a:defRPr>
+          </a:pPr>
+        </a:p>
+      </c:txPr>
+    </c:legend>
+    <c:dispBlanksAs val="gap"/>
+  </c:chart>
+  <c:txPr>
+    <a:bodyPr/>
+    <a:lstStyle/>
+    <a:p>
+      <a:pPr>
+        <a:defRPr sz="1800"/>
+      </a:pPr>
+      <a:endParaRPr lang="en-US"/>
+    </a:p>
+  </c:txPr>
+  <c:externalData r:id="rId1">
+    <c:autoUpdate val="0"/>
+  </c:externalData>
+</c:chartSpace>
+</file>
+
 <file path=ppt/notesMasters/notesMaster1.xml><?xml version="1.0" encoding="utf-8"?>
 <p:notesMaster xmlns:a="http://schemas.openxmlformats.org/drawingml/2006/main" xmlns:p="http://schemas.openxmlformats.org/presentationml/2006/main" xmlns:r="http://schemas.openxmlformats.org/officeDocument/2006/relationships">
   <p:cSld>
@@ -971,7 +1264,7 @@
           <a:lstStyle/>
           <a:p>
             <a:r>
-              <a:t>WIP slide. Framing: full-DAG CBO self-corrects eventually, so coarse guarantees are finite-budget; and when the partition is lossy, fixed-coarse pays the price forever (linear cumulative regret). Hierarchical QCBO makes the partition a starting resolution: plateau trigger -&gt; split incumbent's cluster -&gt; warm start (Prop. 4). Honest positioning: it does NOT beat CBO's regret constant; it removes fixed-coarse's linear term and keeps invariance for clusters never split. Rollback rule + hierarchy discovery = next paper.</a:t>
+              <a:t>Core experiment. Fixed-objective protocol: same SCM, data, seeds, budget; only the assumed structure varies. QCBO-coarse's zeros are byte-identity (Prop. 2 / Theorem 1), verified at 1e-7 tolerance. The inter bow (right-most) is the exact scope boundary: it completes a cluster-level bow, do(C1) becomes non-identifiable, the guarantee is lost. Finest's shifts can even help (decoy deletion) — the point is behavior moves, unpredictably; coarse cannot move.</a:t>
             </a:r>
           </a:p>
         </p:txBody>
@@ -1041,7 +1334,7 @@
           <a:lstStyle/>
           <a:p>
             <a:r>
-              <a:t>GAP = quality + speed in one number. R measures how far you closed the gap to the oracle optimum y*; the speed term rewards reaching that best value early. Key point: GAP only looks at the single best value and when it first appeared.</a:t>
+              <a:t>Positioning slide. BO: robust but weak — the floor. CBO/finest: the ceiling on a correct graph, brittle otherwise. CEO: the field's graph-uncertainty answer — hedging dilutes rather than removes a wrong edge, and DAG-only candidates cannot express a forgotten confounder (P7 zero is representational blindness, daggered in the paper). QCBO-coarse: invariance by construction, priced exactly by the lossy-partition case (next slide).</a:t>
             </a:r>
           </a:p>
         </p:txBody>
@@ -1067,6 +1360,146 @@
 </file>
 
 <file path=ppt/notesSlides/notesSlide3.xml><?xml version="1.0" encoding="utf-8"?>
+<p:notes xmlns:a="http://schemas.openxmlformats.org/drawingml/2006/main" xmlns:p="http://schemas.openxmlformats.org/presentationml/2006/main" xmlns:r="http://schemas.openxmlformats.org/officeDocument/2006/relationships">
+  <p:cSld>
+    <p:spTree>
+      <p:nvGrpSpPr>
+        <p:cNvPr id="1" name=""/>
+        <p:cNvGrpSpPr/>
+        <p:nvPr/>
+      </p:nvGrpSpPr>
+      <p:grpSpPr>
+        <a:xfrm>
+          <a:off x="0" y="0"/>
+          <a:ext cx="0" cy="0"/>
+          <a:chOff x="0" y="0"/>
+          <a:chExt cx="0" cy="0"/>
+        </a:xfrm>
+      </p:grpSpPr>
+      <p:sp>
+        <p:nvSpPr>
+          <p:cNvPr id="2" name="Slide Image Placeholder 1"/>
+          <p:cNvSpPr>
+            <a:spLocks noGrp="1"/>
+          </p:cNvSpPr>
+          <p:nvPr>
+            <p:ph type="sldImg" idx="2"/>
+          </p:nvPr>
+        </p:nvSpPr>
+        <p:spPr/>
+      </p:sp>
+      <p:sp>
+        <p:nvSpPr>
+          <p:cNvPr id="3" name="Notes Placeholder 2"/>
+          <p:cNvSpPr>
+            <a:spLocks noGrp="1"/>
+          </p:cNvSpPr>
+          <p:nvPr>
+            <p:ph type="body" idx="3" sz="quarter"/>
+          </p:nvPr>
+        </p:nvSpPr>
+        <p:spPr/>
+        <p:txBody>
+          <a:bodyPr/>
+          <a:lstStyle/>
+          <a:p>
+            <a:r>
+              <a:t>WIP slide. Framing: full-DAG CBO self-corrects eventually, so coarse guarantees are finite-budget; and when the partition is lossy, fixed-coarse pays the price forever (linear cumulative regret). Hierarchical QCBO makes the partition a starting resolution: plateau trigger -&gt; split incumbent's cluster -&gt; warm start (Prop. 4). Honest positioning: it does NOT beat CBO's regret constant; it removes fixed-coarse's linear term and keeps invariance for clusters never split. Rollback rule + hierarchy discovery = next paper.</a:t>
+            </a:r>
+          </a:p>
+        </p:txBody>
+      </p:sp>
+      <p:sp>
+        <p:nvSpPr>
+          <p:cNvPr id="4" name="Slide Number Placeholder 3"/>
+          <p:cNvSpPr>
+            <a:spLocks noGrp="1"/>
+          </p:cNvSpPr>
+          <p:nvPr>
+            <p:ph type="sldNum" idx="5" sz="quarter"/>
+          </p:nvPr>
+        </p:nvSpPr>
+        <p:spPr/>
+      </p:sp>
+    </p:spTree>
+  </p:cSld>
+  <p:clrMapOvr>
+    <a:masterClrMapping/>
+  </p:clrMapOvr>
+</p:notes>
+</file>
+
+<file path=ppt/notesSlides/notesSlide4.xml><?xml version="1.0" encoding="utf-8"?>
+<p:notes xmlns:a="http://schemas.openxmlformats.org/drawingml/2006/main" xmlns:p="http://schemas.openxmlformats.org/presentationml/2006/main" xmlns:r="http://schemas.openxmlformats.org/officeDocument/2006/relationships">
+  <p:cSld>
+    <p:spTree>
+      <p:nvGrpSpPr>
+        <p:cNvPr id="1" name=""/>
+        <p:cNvGrpSpPr/>
+        <p:nvPr/>
+      </p:nvGrpSpPr>
+      <p:grpSpPr>
+        <a:xfrm>
+          <a:off x="0" y="0"/>
+          <a:ext cx="0" cy="0"/>
+          <a:chOff x="0" y="0"/>
+          <a:chExt cx="0" cy="0"/>
+        </a:xfrm>
+      </p:grpSpPr>
+      <p:sp>
+        <p:nvSpPr>
+          <p:cNvPr id="2" name="Slide Image Placeholder 1"/>
+          <p:cNvSpPr>
+            <a:spLocks noGrp="1"/>
+          </p:cNvSpPr>
+          <p:nvPr>
+            <p:ph type="sldImg" idx="2"/>
+          </p:nvPr>
+        </p:nvSpPr>
+        <p:spPr/>
+      </p:sp>
+      <p:sp>
+        <p:nvSpPr>
+          <p:cNvPr id="3" name="Notes Placeholder 2"/>
+          <p:cNvSpPr>
+            <a:spLocks noGrp="1"/>
+          </p:cNvSpPr>
+          <p:nvPr>
+            <p:ph type="body" idx="3" sz="quarter"/>
+          </p:nvPr>
+        </p:nvSpPr>
+        <p:spPr/>
+        <p:txBody>
+          <a:bodyPr/>
+          <a:lstStyle/>
+          <a:p>
+            <a:r>
+              <a:t>GAP = quality + speed in one number. R measures how far you closed the gap to the oracle optimum y*; the speed term rewards reaching that best value early. Key point: GAP only looks at the single best value and when it first appeared.</a:t>
+            </a:r>
+          </a:p>
+        </p:txBody>
+      </p:sp>
+      <p:sp>
+        <p:nvSpPr>
+          <p:cNvPr id="4" name="Slide Number Placeholder 3"/>
+          <p:cNvSpPr>
+            <a:spLocks noGrp="1"/>
+          </p:cNvSpPr>
+          <p:nvPr>
+            <p:ph type="sldNum" idx="5" sz="quarter"/>
+          </p:nvPr>
+        </p:nvSpPr>
+        <p:spPr/>
+      </p:sp>
+    </p:spTree>
+  </p:cSld>
+  <p:clrMapOvr>
+    <a:masterClrMapping/>
+  </p:clrMapOvr>
+</p:notes>
+</file>
+
+<file path=ppt/notesSlides/notesSlide5.xml><?xml version="1.0" encoding="utf-8"?>
 <p:notes xmlns:a="http://schemas.openxmlformats.org/drawingml/2006/main" xmlns:p="http://schemas.openxmlformats.org/presentationml/2006/main" xmlns:r="http://schemas.openxmlformats.org/officeDocument/2006/relationships">
   <p:cSld>
     <p:spTree>
@@ -7701,6 +8134,1594 @@
 </file>
 
 <file path=ppt/slides/slide7.xml><?xml version="1.0" encoding="utf-8"?>
+<p:sld xmlns:a="http://schemas.openxmlformats.org/drawingml/2006/main" xmlns:p="http://schemas.openxmlformats.org/presentationml/2006/main" xmlns:r="http://schemas.openxmlformats.org/officeDocument/2006/relationships">
+  <p:cSld>
+    <p:bg>
+      <p:bgPr>
+        <a:solidFill>
+          <a:srgbClr val="FFFFFF"/>
+        </a:solidFill>
+        <a:effectLst/>
+      </p:bgPr>
+    </p:bg>
+    <p:spTree>
+      <p:nvGrpSpPr>
+        <p:cNvPr id="1" name=""/>
+        <p:cNvGrpSpPr/>
+        <p:nvPr/>
+      </p:nvGrpSpPr>
+      <p:grpSpPr/>
+      <p:sp>
+        <p:nvSpPr>
+          <p:cNvPr id="2" name="TextBox 1"/>
+          <p:cNvSpPr txBox="1"/>
+          <p:nvPr/>
+        </p:nvSpPr>
+        <p:spPr>
+          <a:xfrm>
+            <a:off x="548640" y="347472"/>
+            <a:ext cx="11064240" cy="685800"/>
+          </a:xfrm>
+          <a:prstGeom prst="rect">
+            <a:avLst/>
+          </a:prstGeom>
+          <a:noFill/>
+        </p:spPr>
+        <p:txBody>
+          <a:bodyPr wrap="square" anchor="t" lIns="0" rIns="0" tIns="0" bIns="0">
+            <a:spAutoFit/>
+          </a:bodyPr>
+          <a:lstStyle/>
+          <a:p>
+            <a:pPr algn="l">
+              <a:lnSpc>
+                <a:spcPct val="105000"/>
+              </a:lnSpc>
+              <a:spcBef>
+                <a:spcPts val="0"/>
+              </a:spcBef>
+              <a:spcAft>
+                <a:spcPts val="400"/>
+              </a:spcAft>
+            </a:pPr>
+            <a:r>
+              <a:rPr sz="3100" b="1">
+                <a:solidFill>
+                  <a:srgbClr val="162A4A"/>
+                </a:solidFill>
+                <a:latin typeface="Cambria"/>
+              </a:rPr>
+              <a:t>A wrong edge, held to the light  (ClusterBench10)</a:t>
+            </a:r>
+          </a:p>
+        </p:txBody>
+      </p:sp>
+      <p:sp>
+        <p:nvSpPr>
+          <p:cNvPr id="3" name="TextBox 2"/>
+          <p:cNvSpPr txBox="1"/>
+          <p:nvPr/>
+        </p:nvSpPr>
+        <p:spPr>
+          <a:xfrm>
+            <a:off x="566928" y="1060704"/>
+            <a:ext cx="11064240" cy="566928"/>
+          </a:xfrm>
+          <a:prstGeom prst="rect">
+            <a:avLst/>
+          </a:prstGeom>
+          <a:noFill/>
+        </p:spPr>
+        <p:txBody>
+          <a:bodyPr wrap="square" anchor="t" lIns="0" rIns="0" tIns="0" bIns="0">
+            <a:spAutoFit/>
+          </a:bodyPr>
+          <a:lstStyle/>
+          <a:p>
+            <a:pPr algn="l">
+              <a:lnSpc>
+                <a:spcPct val="108000"/>
+              </a:lnSpc>
+              <a:spcBef>
+                <a:spcPts val="0"/>
+              </a:spcBef>
+              <a:spcAft>
+                <a:spcPts val="400"/>
+              </a:spcAft>
+            </a:pPr>
+            <a:r>
+              <a:rPr sz="1550" b="0">
+                <a:solidFill>
+                  <a:srgbClr val="5B6B7B"/>
+                </a:solidFill>
+                <a:latin typeface="Calibri"/>
+              </a:rPr>
+              <a:t>Objective held fixed; only the structure each method reasons with is perturbed. ΔGAP@100 = misspecified − correct, paired by seed (10 seeds, T=100).</a:t>
+            </a:r>
+          </a:p>
+        </p:txBody>
+      </p:sp>
+      <p:sp>
+        <p:nvSpPr>
+          <p:cNvPr id="4" name="Oval 3"/>
+          <p:cNvSpPr/>
+          <p:nvPr/>
+        </p:nvSpPr>
+        <p:spPr>
+          <a:xfrm>
+            <a:off x="548640" y="1847088"/>
+            <a:ext cx="146304" cy="146304"/>
+          </a:xfrm>
+          <a:prstGeom prst="ellipse">
+            <a:avLst/>
+          </a:prstGeom>
+          <a:solidFill>
+            <a:srgbClr val="0E8388"/>
+          </a:solidFill>
+          <a:ln>
+            <a:noFill/>
+          </a:ln>
+          <a:effectLst/>
+        </p:spPr>
+        <p:style>
+          <a:lnRef idx="1">
+            <a:schemeClr val="accent1"/>
+          </a:lnRef>
+          <a:fillRef idx="3">
+            <a:schemeClr val="accent1"/>
+          </a:fillRef>
+          <a:effectRef idx="2">
+            <a:schemeClr val="accent1"/>
+          </a:effectRef>
+          <a:fontRef idx="minor">
+            <a:schemeClr val="lt1"/>
+          </a:fontRef>
+        </p:style>
+        <p:txBody>
+          <a:bodyPr rtlCol="0" anchor="ctr"/>
+          <a:lstStyle/>
+          <a:p>
+            <a:pPr algn="ctr"/>
+          </a:p>
+        </p:txBody>
+      </p:sp>
+      <p:sp>
+        <p:nvSpPr>
+          <p:cNvPr id="5" name="TextBox 4"/>
+          <p:cNvSpPr txBox="1"/>
+          <p:nvPr/>
+        </p:nvSpPr>
+        <p:spPr>
+          <a:xfrm>
+            <a:off x="804672" y="1746504"/>
+            <a:ext cx="3904487" cy="411480"/>
+          </a:xfrm>
+          <a:prstGeom prst="rect">
+            <a:avLst/>
+          </a:prstGeom>
+          <a:noFill/>
+        </p:spPr>
+        <p:txBody>
+          <a:bodyPr wrap="square" anchor="t" lIns="0" rIns="0" tIns="0" bIns="0">
+            <a:spAutoFit/>
+          </a:bodyPr>
+          <a:lstStyle/>
+          <a:p>
+            <a:pPr algn="l">
+              <a:lnSpc>
+                <a:spcPct val="105000"/>
+              </a:lnSpc>
+              <a:spcBef>
+                <a:spcPts val="0"/>
+              </a:spcBef>
+              <a:spcAft>
+                <a:spcPts val="400"/>
+              </a:spcAft>
+            </a:pPr>
+            <a:r>
+              <a:rPr sz="1750" b="1">
+                <a:solidFill>
+                  <a:srgbClr val="162A4A"/>
+                </a:solidFill>
+                <a:latin typeface="Cambria"/>
+              </a:rPr>
+              <a:t>How a wrong graph does damage</a:t>
+            </a:r>
+          </a:p>
+        </p:txBody>
+      </p:sp>
+      <p:sp>
+        <p:nvSpPr>
+          <p:cNvPr id="6" name="TextBox 5"/>
+          <p:cNvSpPr txBox="1"/>
+          <p:nvPr/>
+        </p:nvSpPr>
+        <p:spPr>
+          <a:xfrm>
+            <a:off x="804672" y="2212848"/>
+            <a:ext cx="3904487" cy="1463040"/>
+          </a:xfrm>
+          <a:prstGeom prst="rect">
+            <a:avLst/>
+          </a:prstGeom>
+          <a:noFill/>
+        </p:spPr>
+        <p:txBody>
+          <a:bodyPr wrap="square" anchor="t" lIns="0" rIns="0" tIns="0" bIns="0">
+            <a:spAutoFit/>
+          </a:bodyPr>
+          <a:lstStyle/>
+          <a:p>
+            <a:pPr algn="l">
+              <a:lnSpc>
+                <a:spcPct val="110000"/>
+              </a:lnSpc>
+              <a:spcBef>
+                <a:spcPts val="0"/>
+              </a:spcBef>
+              <a:spcAft>
+                <a:spcPts val="700"/>
+              </a:spcAft>
+            </a:pPr>
+            <a:r>
+              <a:rPr sz="1450" b="1">
+                <a:solidFill>
+                  <a:srgbClr val="243242"/>
+                </a:solidFill>
+                <a:latin typeface="Calibri"/>
+              </a:rPr>
+              <a:t>Prior bias — </a:t>
+            </a:r>
+            <a:r>
+              <a:rPr sz="1450" b="0">
+                <a:solidFill>
+                  <a:srgbClr val="243242"/>
+                </a:solidFill>
+                <a:latin typeface="Calibri"/>
+              </a:rPr>
+              <a:t>the do-calculus prior is a functional of the graph; a wrong edge biases it and wastes evaluations.</a:t>
+            </a:r>
+          </a:p>
+          <a:p>
+            <a:pPr algn="l">
+              <a:lnSpc>
+                <a:spcPct val="110000"/>
+              </a:lnSpc>
+              <a:spcBef>
+                <a:spcPts val="0"/>
+              </a:spcBef>
+              <a:spcAft>
+                <a:spcPts val="700"/>
+              </a:spcAft>
+            </a:pPr>
+            <a:r>
+              <a:rPr sz="1450" b="1">
+                <a:solidFill>
+                  <a:srgbClr val="243242"/>
+                </a:solidFill>
+                <a:latin typeface="Calibri"/>
+              </a:rPr>
+              <a:t>Arm deletion — </a:t>
+            </a:r>
+            <a:r>
+              <a:rPr sz="1450" b="0">
+                <a:solidFill>
+                  <a:srgbClr val="243242"/>
+                </a:solidFill>
+                <a:latin typeface="Calibri"/>
+              </a:rPr>
+              <a:t>a flipped identifiability verdict removes candidate arms — sometimes the optimal one.</a:t>
+            </a:r>
+          </a:p>
+        </p:txBody>
+      </p:sp>
+      <p:sp>
+        <p:nvSpPr>
+          <p:cNvPr id="7" name="Rounded Rectangle 6"/>
+          <p:cNvSpPr/>
+          <p:nvPr/>
+        </p:nvSpPr>
+        <p:spPr>
+          <a:xfrm>
+            <a:off x="548640" y="3950208"/>
+            <a:ext cx="4160520" cy="2103120"/>
+          </a:xfrm>
+          <a:prstGeom prst="roundRect">
+            <a:avLst>
+              <a:gd name="adj" fmla="val 7000"/>
+            </a:avLst>
+          </a:prstGeom>
+          <a:solidFill>
+            <a:srgbClr val="E6F2F2"/>
+          </a:solidFill>
+          <a:ln>
+            <a:noFill/>
+          </a:ln>
+          <a:effectLst>
+            <a:outerShdw blurRad="90000" dist="38000" dir="5400000" rotWithShape="0">
+              <a:srgbClr val="9AA6B2">
+                <a:alpha val="26000"/>
+              </a:srgbClr>
+            </a:outerShdw>
+          </a:effectLst>
+        </p:spPr>
+        <p:style>
+          <a:lnRef idx="1">
+            <a:schemeClr val="accent1"/>
+          </a:lnRef>
+          <a:fillRef idx="3">
+            <a:schemeClr val="accent1"/>
+          </a:fillRef>
+          <a:effectRef idx="2">
+            <a:schemeClr val="accent1"/>
+          </a:effectRef>
+          <a:fontRef idx="minor">
+            <a:schemeClr val="lt1"/>
+          </a:fontRef>
+        </p:style>
+        <p:txBody>
+          <a:bodyPr rtlCol="0" anchor="ctr"/>
+          <a:lstStyle/>
+          <a:p>
+            <a:pPr algn="ctr"/>
+          </a:p>
+        </p:txBody>
+      </p:sp>
+      <p:sp>
+        <p:nvSpPr>
+          <p:cNvPr id="8" name="TextBox 7"/>
+          <p:cNvSpPr txBox="1"/>
+          <p:nvPr/>
+        </p:nvSpPr>
+        <p:spPr>
+          <a:xfrm>
+            <a:off x="822959" y="4169664"/>
+            <a:ext cx="3611879" cy="365760"/>
+          </a:xfrm>
+          <a:prstGeom prst="rect">
+            <a:avLst/>
+          </a:prstGeom>
+          <a:noFill/>
+        </p:spPr>
+        <p:txBody>
+          <a:bodyPr wrap="square" anchor="t" lIns="0" rIns="0" tIns="0" bIns="0">
+            <a:spAutoFit/>
+          </a:bodyPr>
+          <a:lstStyle/>
+          <a:p>
+            <a:pPr algn="l">
+              <a:lnSpc>
+                <a:spcPct val="105000"/>
+              </a:lnSpc>
+              <a:spcBef>
+                <a:spcPts val="0"/>
+              </a:spcBef>
+              <a:spcAft>
+                <a:spcPts val="400"/>
+              </a:spcAft>
+            </a:pPr>
+            <a:r>
+              <a:rPr sz="1450" b="1">
+                <a:solidFill>
+                  <a:srgbClr val="0E8388"/>
+                </a:solidFill>
+                <a:latin typeface="Calibri"/>
+              </a:rPr>
+              <a:t>The contract, kept</a:t>
+            </a:r>
+          </a:p>
+        </p:txBody>
+      </p:sp>
+      <p:sp>
+        <p:nvSpPr>
+          <p:cNvPr id="9" name="TextBox 8"/>
+          <p:cNvSpPr txBox="1"/>
+          <p:nvPr/>
+        </p:nvSpPr>
+        <p:spPr>
+          <a:xfrm>
+            <a:off x="822959" y="4572000"/>
+            <a:ext cx="3611879" cy="1371600"/>
+          </a:xfrm>
+          <a:prstGeom prst="rect">
+            <a:avLst/>
+          </a:prstGeom>
+          <a:noFill/>
+        </p:spPr>
+        <p:txBody>
+          <a:bodyPr wrap="square" anchor="t" lIns="0" rIns="0" tIns="0" bIns="0">
+            <a:spAutoFit/>
+          </a:bodyPr>
+          <a:lstStyle/>
+          <a:p>
+            <a:pPr algn="l">
+              <a:lnSpc>
+                <a:spcPct val="112000"/>
+              </a:lnSpc>
+              <a:spcBef>
+                <a:spcPts val="0"/>
+              </a:spcBef>
+              <a:spcAft>
+                <a:spcPts val="400"/>
+              </a:spcAft>
+            </a:pPr>
+            <a:r>
+              <a:rPr sz="1450" b="0">
+                <a:solidFill>
+                  <a:srgbClr val="243242"/>
+                </a:solidFill>
+                <a:latin typeface="Calibri"/>
+              </a:rPr>
+              <a:t>QCBO-coarse is byte-identical to its correct-graph run on 8 of 9 perturbations — exact zeros, not small numbers. Full-DAG CBO (= QCBO-finest) shifts on every edge it can see.</a:t>
+            </a:r>
+          </a:p>
+        </p:txBody>
+      </p:sp>
+      <p:graphicFrame>
+        <p:nvGraphicFramePr>
+          <p:cNvPr id="10" name="Chart 9"/>
+          <p:cNvGraphicFramePr>
+            <a:graphicFrameLocks noGrp="1"/>
+          </p:cNvGraphicFramePr>
+          <p:nvPr/>
+        </p:nvGraphicFramePr>
+        <p:xfrm>
+          <a:off x="5029200" y="1700784"/>
+          <a:ext cx="6583680" cy="4480560"/>
+        </p:xfrm>
+        <a:graphic>
+          <a:graphicData uri="http://schemas.openxmlformats.org/drawingml/2006/chart">
+            <c:chart xmlns:c="http://schemas.openxmlformats.org/drawingml/2006/chart" r:id="rId2"/>
+          </a:graphicData>
+        </a:graphic>
+      </p:graphicFrame>
+      <p:sp>
+        <p:nvSpPr>
+          <p:cNvPr id="11" name="TextBox 10"/>
+          <p:cNvSpPr txBox="1"/>
+          <p:nvPr/>
+        </p:nvSpPr>
+        <p:spPr>
+          <a:xfrm>
+            <a:off x="5120640" y="6236208"/>
+            <a:ext cx="6400800" cy="457200"/>
+          </a:xfrm>
+          <a:prstGeom prst="rect">
+            <a:avLst/>
+          </a:prstGeom>
+          <a:noFill/>
+        </p:spPr>
+        <p:txBody>
+          <a:bodyPr wrap="square" anchor="t" lIns="0" rIns="0" tIns="0" bIns="0">
+            <a:spAutoFit/>
+          </a:bodyPr>
+          <a:lstStyle/>
+          <a:p>
+            <a:pPr algn="l">
+              <a:lnSpc>
+                <a:spcPct val="105000"/>
+              </a:lnSpc>
+              <a:spcBef>
+                <a:spcPts val="0"/>
+              </a:spcBef>
+              <a:spcAft>
+                <a:spcPts val="400"/>
+              </a:spcAft>
+            </a:pPr>
+            <a:r>
+              <a:rPr sz="1150" b="0" i="1">
+                <a:solidFill>
+                  <a:srgbClr val="5B6B7B"/>
+                </a:solidFill>
+                <a:latin typeface="Calibri"/>
+              </a:rPr>
+              <a:t>ΔGAP@100 per perturbation (0 = unchanged). QCBO-coarse: exact zeros everywhere except the inter-cluster bow — the guarantee's precise boundary.</a:t>
+            </a:r>
+          </a:p>
+        </p:txBody>
+      </p:sp>
+    </p:spTree>
+  </p:cSld>
+  <p:clrMapOvr>
+    <a:masterClrMapping/>
+  </p:clrMapOvr>
+</p:sld>
+</file>
+
+<file path=ppt/slides/slide8.xml><?xml version="1.0" encoding="utf-8"?>
+<p:sld xmlns:a="http://schemas.openxmlformats.org/drawingml/2006/main" xmlns:p="http://schemas.openxmlformats.org/presentationml/2006/main" xmlns:r="http://schemas.openxmlformats.org/officeDocument/2006/relationships">
+  <p:cSld>
+    <p:bg>
+      <p:bgPr>
+        <a:solidFill>
+          <a:srgbClr val="FFFFFF"/>
+        </a:solidFill>
+        <a:effectLst/>
+      </p:bgPr>
+    </p:bg>
+    <p:spTree>
+      <p:nvGrpSpPr>
+        <p:cNvPr id="1" name=""/>
+        <p:cNvGrpSpPr/>
+        <p:nvPr/>
+      </p:nvGrpSpPr>
+      <p:grpSpPr/>
+      <p:sp>
+        <p:nvSpPr>
+          <p:cNvPr id="2" name="TextBox 1"/>
+          <p:cNvSpPr txBox="1"/>
+          <p:nvPr/>
+        </p:nvSpPr>
+        <p:spPr>
+          <a:xfrm>
+            <a:off x="548640" y="347472"/>
+            <a:ext cx="11064240" cy="685800"/>
+          </a:xfrm>
+          <a:prstGeom prst="rect">
+            <a:avLst/>
+          </a:prstGeom>
+          <a:noFill/>
+        </p:spPr>
+        <p:txBody>
+          <a:bodyPr wrap="square" anchor="t" lIns="0" rIns="0" tIns="0" bIns="0">
+            <a:spAutoFit/>
+          </a:bodyPr>
+          <a:lstStyle/>
+          <a:p>
+            <a:pPr algn="l">
+              <a:lnSpc>
+                <a:spcPct val="105000"/>
+              </a:lnSpc>
+              <a:spcBef>
+                <a:spcPts val="0"/>
+              </a:spcBef>
+              <a:spcAft>
+                <a:spcPts val="400"/>
+              </a:spcAft>
+            </a:pPr>
+            <a:r>
+              <a:rPr sz="3100" b="1">
+                <a:solidFill>
+                  <a:srgbClr val="162A4A"/>
+                </a:solidFill>
+                <a:latin typeface="Cambria"/>
+              </a:rPr>
+              <a:t>The field under the same wrong graphs</a:t>
+            </a:r>
+          </a:p>
+        </p:txBody>
+      </p:sp>
+      <p:sp>
+        <p:nvSpPr>
+          <p:cNvPr id="3" name="TextBox 2"/>
+          <p:cNvSpPr txBox="1"/>
+          <p:nvPr/>
+        </p:nvSpPr>
+        <p:spPr>
+          <a:xfrm>
+            <a:off x="566928" y="1060704"/>
+            <a:ext cx="11064240" cy="548640"/>
+          </a:xfrm>
+          <a:prstGeom prst="rect">
+            <a:avLst/>
+          </a:prstGeom>
+          <a:noFill/>
+        </p:spPr>
+        <p:txBody>
+          <a:bodyPr wrap="square" anchor="t" lIns="0" rIns="0" tIns="0" bIns="0">
+            <a:spAutoFit/>
+          </a:bodyPr>
+          <a:lstStyle/>
+          <a:p>
+            <a:pPr algn="l">
+              <a:lnSpc>
+                <a:spcPct val="105000"/>
+              </a:lnSpc>
+              <a:spcBef>
+                <a:spcPts val="0"/>
+              </a:spcBef>
+              <a:spcAft>
+                <a:spcPts val="400"/>
+              </a:spcAft>
+            </a:pPr>
+            <a:r>
+              <a:rPr sz="1550" b="0">
+                <a:solidFill>
+                  <a:srgbClr val="5B6B7B"/>
+                </a:solidFill>
+                <a:latin typeface="Calibri"/>
+              </a:rPr>
+              <a:t>Four ways to hold a structural belief — and what each pays when an edge inside a cluster is wrong.</a:t>
+            </a:r>
+          </a:p>
+        </p:txBody>
+      </p:sp>
+      <p:sp>
+        <p:nvSpPr>
+          <p:cNvPr id="4" name="Rounded Rectangle 3"/>
+          <p:cNvSpPr/>
+          <p:nvPr/>
+        </p:nvSpPr>
+        <p:spPr>
+          <a:xfrm>
+            <a:off x="548640" y="1737360"/>
+            <a:ext cx="11064240" cy="1042415"/>
+          </a:xfrm>
+          <a:prstGeom prst="roundRect">
+            <a:avLst>
+              <a:gd name="adj" fmla="val 6000"/>
+            </a:avLst>
+          </a:prstGeom>
+          <a:solidFill>
+            <a:srgbClr val="FFFFFF"/>
+          </a:solidFill>
+          <a:ln w="12700">
+            <a:solidFill>
+              <a:srgbClr val="D8DEE4"/>
+            </a:solidFill>
+          </a:ln>
+          <a:effectLst>
+            <a:outerShdw blurRad="90000" dist="38000" dir="5400000" rotWithShape="0">
+              <a:srgbClr val="9AA6B2">
+                <a:alpha val="26000"/>
+              </a:srgbClr>
+            </a:outerShdw>
+          </a:effectLst>
+        </p:spPr>
+        <p:style>
+          <a:lnRef idx="1">
+            <a:schemeClr val="accent1"/>
+          </a:lnRef>
+          <a:fillRef idx="3">
+            <a:schemeClr val="accent1"/>
+          </a:fillRef>
+          <a:effectRef idx="2">
+            <a:schemeClr val="accent1"/>
+          </a:effectRef>
+          <a:fontRef idx="minor">
+            <a:schemeClr val="lt1"/>
+          </a:fontRef>
+        </p:style>
+        <p:txBody>
+          <a:bodyPr rtlCol="0" anchor="ctr"/>
+          <a:lstStyle/>
+          <a:p>
+            <a:pPr algn="ctr"/>
+          </a:p>
+        </p:txBody>
+      </p:sp>
+      <p:sp>
+        <p:nvSpPr>
+          <p:cNvPr id="5" name="Oval 4"/>
+          <p:cNvSpPr/>
+          <p:nvPr/>
+        </p:nvSpPr>
+        <p:spPr>
+          <a:xfrm>
+            <a:off x="841248" y="2148840"/>
+            <a:ext cx="219456" cy="219456"/>
+          </a:xfrm>
+          <a:prstGeom prst="ellipse">
+            <a:avLst/>
+          </a:prstGeom>
+          <a:solidFill>
+            <a:srgbClr val="999999"/>
+          </a:solidFill>
+          <a:ln>
+            <a:noFill/>
+          </a:ln>
+          <a:effectLst/>
+        </p:spPr>
+        <p:style>
+          <a:lnRef idx="1">
+            <a:schemeClr val="accent1"/>
+          </a:lnRef>
+          <a:fillRef idx="3">
+            <a:schemeClr val="accent1"/>
+          </a:fillRef>
+          <a:effectRef idx="2">
+            <a:schemeClr val="accent1"/>
+          </a:effectRef>
+          <a:fontRef idx="minor">
+            <a:schemeClr val="lt1"/>
+          </a:fontRef>
+        </p:style>
+        <p:txBody>
+          <a:bodyPr rtlCol="0" anchor="ctr"/>
+          <a:lstStyle/>
+          <a:p>
+            <a:pPr algn="ctr"/>
+          </a:p>
+        </p:txBody>
+      </p:sp>
+      <p:sp>
+        <p:nvSpPr>
+          <p:cNvPr id="6" name="TextBox 5"/>
+          <p:cNvSpPr txBox="1"/>
+          <p:nvPr/>
+        </p:nvSpPr>
+        <p:spPr>
+          <a:xfrm>
+            <a:off x="1243584" y="1874519"/>
+            <a:ext cx="3017520" cy="457200"/>
+          </a:xfrm>
+          <a:prstGeom prst="rect">
+            <a:avLst/>
+          </a:prstGeom>
+          <a:noFill/>
+        </p:spPr>
+        <p:txBody>
+          <a:bodyPr wrap="square" anchor="t" lIns="0" rIns="0" tIns="0" bIns="0">
+            <a:spAutoFit/>
+          </a:bodyPr>
+          <a:lstStyle/>
+          <a:p>
+            <a:pPr algn="l">
+              <a:lnSpc>
+                <a:spcPct val="105000"/>
+              </a:lnSpc>
+              <a:spcBef>
+                <a:spcPts val="0"/>
+              </a:spcBef>
+              <a:spcAft>
+                <a:spcPts val="400"/>
+              </a:spcAft>
+            </a:pPr>
+            <a:r>
+              <a:rPr sz="1650" b="1">
+                <a:solidFill>
+                  <a:srgbClr val="162A4A"/>
+                </a:solidFill>
+                <a:latin typeface="Calibri"/>
+              </a:rPr>
+              <a:t>BO</a:t>
+            </a:r>
+          </a:p>
+        </p:txBody>
+      </p:sp>
+      <p:sp>
+        <p:nvSpPr>
+          <p:cNvPr id="7" name="TextBox 6"/>
+          <p:cNvSpPr txBox="1"/>
+          <p:nvPr/>
+        </p:nvSpPr>
+        <p:spPr>
+          <a:xfrm>
+            <a:off x="1243584" y="2286000"/>
+            <a:ext cx="3017520" cy="411480"/>
+          </a:xfrm>
+          <a:prstGeom prst="rect">
+            <a:avLst/>
+          </a:prstGeom>
+          <a:noFill/>
+        </p:spPr>
+        <p:txBody>
+          <a:bodyPr wrap="square" anchor="t" lIns="0" rIns="0" tIns="0" bIns="0">
+            <a:spAutoFit/>
+          </a:bodyPr>
+          <a:lstStyle/>
+          <a:p>
+            <a:pPr algn="l">
+              <a:lnSpc>
+                <a:spcPct val="105000"/>
+              </a:lnSpc>
+              <a:spcBef>
+                <a:spcPts val="0"/>
+              </a:spcBef>
+              <a:spcAft>
+                <a:spcPts val="400"/>
+              </a:spcAft>
+            </a:pPr>
+            <a:r>
+              <a:rPr sz="1250" b="0" i="1">
+                <a:solidFill>
+                  <a:srgbClr val="5B6B7B"/>
+                </a:solidFill>
+                <a:latin typeface="Calibri"/>
+              </a:rPr>
+              <a:t>ignores structure</a:t>
+            </a:r>
+          </a:p>
+        </p:txBody>
+      </p:sp>
+      <p:sp>
+        <p:nvSpPr>
+          <p:cNvPr id="8" name="TextBox 7"/>
+          <p:cNvSpPr txBox="1"/>
+          <p:nvPr/>
+        </p:nvSpPr>
+        <p:spPr>
+          <a:xfrm>
+            <a:off x="4434840" y="1847088"/>
+            <a:ext cx="6949440" cy="841248"/>
+          </a:xfrm>
+          <a:prstGeom prst="rect">
+            <a:avLst/>
+          </a:prstGeom>
+          <a:noFill/>
+        </p:spPr>
+        <p:txBody>
+          <a:bodyPr wrap="square" anchor="ctr" lIns="0" rIns="0" tIns="0" bIns="0">
+            <a:spAutoFit/>
+          </a:bodyPr>
+          <a:lstStyle/>
+          <a:p>
+            <a:pPr algn="l">
+              <a:lnSpc>
+                <a:spcPct val="110000"/>
+              </a:lnSpc>
+              <a:spcBef>
+                <a:spcPts val="0"/>
+              </a:spcBef>
+              <a:spcAft>
+                <a:spcPts val="400"/>
+              </a:spcAft>
+            </a:pPr>
+            <a:r>
+              <a:rPr sz="1300" b="0">
+                <a:solidFill>
+                  <a:srgbClr val="243242"/>
+                </a:solidFill>
+                <a:latin typeface="Calibri"/>
+              </a:rPr>
+              <a:t>Invariant by blindness — and worst absolute Y (final 1.98). Robustness is not ignoring structure.</a:t>
+            </a:r>
+          </a:p>
+        </p:txBody>
+      </p:sp>
+      <p:sp>
+        <p:nvSpPr>
+          <p:cNvPr id="9" name="Rounded Rectangle 8"/>
+          <p:cNvSpPr/>
+          <p:nvPr/>
+        </p:nvSpPr>
+        <p:spPr>
+          <a:xfrm>
+            <a:off x="548640" y="2926080"/>
+            <a:ext cx="11064240" cy="1042415"/>
+          </a:xfrm>
+          <a:prstGeom prst="roundRect">
+            <a:avLst>
+              <a:gd name="adj" fmla="val 6000"/>
+            </a:avLst>
+          </a:prstGeom>
+          <a:solidFill>
+            <a:srgbClr val="FFFFFF"/>
+          </a:solidFill>
+          <a:ln w="12700">
+            <a:solidFill>
+              <a:srgbClr val="D8DEE4"/>
+            </a:solidFill>
+          </a:ln>
+          <a:effectLst>
+            <a:outerShdw blurRad="90000" dist="38000" dir="5400000" rotWithShape="0">
+              <a:srgbClr val="9AA6B2">
+                <a:alpha val="26000"/>
+              </a:srgbClr>
+            </a:outerShdw>
+          </a:effectLst>
+        </p:spPr>
+        <p:style>
+          <a:lnRef idx="1">
+            <a:schemeClr val="accent1"/>
+          </a:lnRef>
+          <a:fillRef idx="3">
+            <a:schemeClr val="accent1"/>
+          </a:fillRef>
+          <a:effectRef idx="2">
+            <a:schemeClr val="accent1"/>
+          </a:effectRef>
+          <a:fontRef idx="minor">
+            <a:schemeClr val="lt1"/>
+          </a:fontRef>
+        </p:style>
+        <p:txBody>
+          <a:bodyPr rtlCol="0" anchor="ctr"/>
+          <a:lstStyle/>
+          <a:p>
+            <a:pPr algn="ctr"/>
+          </a:p>
+        </p:txBody>
+      </p:sp>
+      <p:sp>
+        <p:nvSpPr>
+          <p:cNvPr id="10" name="Oval 9"/>
+          <p:cNvSpPr/>
+          <p:nvPr/>
+        </p:nvSpPr>
+        <p:spPr>
+          <a:xfrm>
+            <a:off x="841248" y="3337560"/>
+            <a:ext cx="219456" cy="219456"/>
+          </a:xfrm>
+          <a:prstGeom prst="ellipse">
+            <a:avLst/>
+          </a:prstGeom>
+          <a:solidFill>
+            <a:srgbClr val="E69F00"/>
+          </a:solidFill>
+          <a:ln>
+            <a:noFill/>
+          </a:ln>
+          <a:effectLst/>
+        </p:spPr>
+        <p:style>
+          <a:lnRef idx="1">
+            <a:schemeClr val="accent1"/>
+          </a:lnRef>
+          <a:fillRef idx="3">
+            <a:schemeClr val="accent1"/>
+          </a:fillRef>
+          <a:effectRef idx="2">
+            <a:schemeClr val="accent1"/>
+          </a:effectRef>
+          <a:fontRef idx="minor">
+            <a:schemeClr val="lt1"/>
+          </a:fontRef>
+        </p:style>
+        <p:txBody>
+          <a:bodyPr rtlCol="0" anchor="ctr"/>
+          <a:lstStyle/>
+          <a:p>
+            <a:pPr algn="ctr"/>
+          </a:p>
+        </p:txBody>
+      </p:sp>
+      <p:sp>
+        <p:nvSpPr>
+          <p:cNvPr id="11" name="TextBox 10"/>
+          <p:cNvSpPr txBox="1"/>
+          <p:nvPr/>
+        </p:nvSpPr>
+        <p:spPr>
+          <a:xfrm>
+            <a:off x="1243584" y="3063240"/>
+            <a:ext cx="3017520" cy="457200"/>
+          </a:xfrm>
+          <a:prstGeom prst="rect">
+            <a:avLst/>
+          </a:prstGeom>
+          <a:noFill/>
+        </p:spPr>
+        <p:txBody>
+          <a:bodyPr wrap="square" anchor="t" lIns="0" rIns="0" tIns="0" bIns="0">
+            <a:spAutoFit/>
+          </a:bodyPr>
+          <a:lstStyle/>
+          <a:p>
+            <a:pPr algn="l">
+              <a:lnSpc>
+                <a:spcPct val="105000"/>
+              </a:lnSpc>
+              <a:spcBef>
+                <a:spcPts val="0"/>
+              </a:spcBef>
+              <a:spcAft>
+                <a:spcPts val="400"/>
+              </a:spcAft>
+            </a:pPr>
+            <a:r>
+              <a:rPr sz="1650" b="1">
+                <a:solidFill>
+                  <a:srgbClr val="162A4A"/>
+                </a:solidFill>
+                <a:latin typeface="Calibri"/>
+              </a:rPr>
+              <a:t>CBO ≡ QCBO-finest</a:t>
+            </a:r>
+          </a:p>
+        </p:txBody>
+      </p:sp>
+      <p:sp>
+        <p:nvSpPr>
+          <p:cNvPr id="12" name="TextBox 11"/>
+          <p:cNvSpPr txBox="1"/>
+          <p:nvPr/>
+        </p:nvSpPr>
+        <p:spPr>
+          <a:xfrm>
+            <a:off x="1243584" y="3474720"/>
+            <a:ext cx="3017520" cy="411480"/>
+          </a:xfrm>
+          <a:prstGeom prst="rect">
+            <a:avLst/>
+          </a:prstGeom>
+          <a:noFill/>
+        </p:spPr>
+        <p:txBody>
+          <a:bodyPr wrap="square" anchor="t" lIns="0" rIns="0" tIns="0" bIns="0">
+            <a:spAutoFit/>
+          </a:bodyPr>
+          <a:lstStyle/>
+          <a:p>
+            <a:pPr algn="l">
+              <a:lnSpc>
+                <a:spcPct val="105000"/>
+              </a:lnSpc>
+              <a:spcBef>
+                <a:spcPts val="0"/>
+              </a:spcBef>
+              <a:spcAft>
+                <a:spcPts val="400"/>
+              </a:spcAft>
+            </a:pPr>
+            <a:r>
+              <a:rPr sz="1250" b="0" i="1">
+                <a:solidFill>
+                  <a:srgbClr val="5B6B7B"/>
+                </a:solidFill>
+                <a:latin typeface="Calibri"/>
+              </a:rPr>
+              <a:t>trusts the full DAG</a:t>
+            </a:r>
+          </a:p>
+        </p:txBody>
+      </p:sp>
+      <p:sp>
+        <p:nvSpPr>
+          <p:cNvPr id="13" name="TextBox 12"/>
+          <p:cNvSpPr txBox="1"/>
+          <p:nvPr/>
+        </p:nvSpPr>
+        <p:spPr>
+          <a:xfrm>
+            <a:off x="4434840" y="3035808"/>
+            <a:ext cx="6949440" cy="841248"/>
+          </a:xfrm>
+          <a:prstGeom prst="rect">
+            <a:avLst/>
+          </a:prstGeom>
+          <a:noFill/>
+        </p:spPr>
+        <p:txBody>
+          <a:bodyPr wrap="square" anchor="ctr" lIns="0" rIns="0" tIns="0" bIns="0">
+            <a:spAutoFit/>
+          </a:bodyPr>
+          <a:lstStyle/>
+          <a:p>
+            <a:pPr algn="l">
+              <a:lnSpc>
+                <a:spcPct val="110000"/>
+              </a:lnSpc>
+              <a:spcBef>
+                <a:spcPts val="0"/>
+              </a:spcBef>
+              <a:spcAft>
+                <a:spcPts val="400"/>
+              </a:spcAft>
+            </a:pPr>
+            <a:r>
+              <a:rPr sz="1300" b="0">
+                <a:solidFill>
+                  <a:srgbClr val="243242"/>
+                </a:solidFill>
+                <a:latin typeface="Calibri"/>
+              </a:rPr>
+              <a:t>Complete ID on the assumed DAG: every visible edge feeds the prior and the arm gate, so every visible edit moves GAP/PA-GAP (final Y 0.29 on the correct graph).</a:t>
+            </a:r>
+          </a:p>
+        </p:txBody>
+      </p:sp>
+      <p:sp>
+        <p:nvSpPr>
+          <p:cNvPr id="14" name="Rounded Rectangle 13"/>
+          <p:cNvSpPr/>
+          <p:nvPr/>
+        </p:nvSpPr>
+        <p:spPr>
+          <a:xfrm>
+            <a:off x="548640" y="4114800"/>
+            <a:ext cx="11064240" cy="1042415"/>
+          </a:xfrm>
+          <a:prstGeom prst="roundRect">
+            <a:avLst>
+              <a:gd name="adj" fmla="val 6000"/>
+            </a:avLst>
+          </a:prstGeom>
+          <a:solidFill>
+            <a:srgbClr val="FFFFFF"/>
+          </a:solidFill>
+          <a:ln w="12700">
+            <a:solidFill>
+              <a:srgbClr val="D8DEE4"/>
+            </a:solidFill>
+          </a:ln>
+          <a:effectLst>
+            <a:outerShdw blurRad="90000" dist="38000" dir="5400000" rotWithShape="0">
+              <a:srgbClr val="9AA6B2">
+                <a:alpha val="26000"/>
+              </a:srgbClr>
+            </a:outerShdw>
+          </a:effectLst>
+        </p:spPr>
+        <p:style>
+          <a:lnRef idx="1">
+            <a:schemeClr val="accent1"/>
+          </a:lnRef>
+          <a:fillRef idx="3">
+            <a:schemeClr val="accent1"/>
+          </a:fillRef>
+          <a:effectRef idx="2">
+            <a:schemeClr val="accent1"/>
+          </a:effectRef>
+          <a:fontRef idx="minor">
+            <a:schemeClr val="lt1"/>
+          </a:fontRef>
+        </p:style>
+        <p:txBody>
+          <a:bodyPr rtlCol="0" anchor="ctr"/>
+          <a:lstStyle/>
+          <a:p>
+            <a:pPr algn="ctr"/>
+          </a:p>
+        </p:txBody>
+      </p:sp>
+      <p:sp>
+        <p:nvSpPr>
+          <p:cNvPr id="15" name="Oval 14"/>
+          <p:cNvSpPr/>
+          <p:nvPr/>
+        </p:nvSpPr>
+        <p:spPr>
+          <a:xfrm>
+            <a:off x="841248" y="4526280"/>
+            <a:ext cx="219456" cy="219456"/>
+          </a:xfrm>
+          <a:prstGeom prst="ellipse">
+            <a:avLst/>
+          </a:prstGeom>
+          <a:solidFill>
+            <a:srgbClr val="009E73"/>
+          </a:solidFill>
+          <a:ln>
+            <a:noFill/>
+          </a:ln>
+          <a:effectLst/>
+        </p:spPr>
+        <p:style>
+          <a:lnRef idx="1">
+            <a:schemeClr val="accent1"/>
+          </a:lnRef>
+          <a:fillRef idx="3">
+            <a:schemeClr val="accent1"/>
+          </a:fillRef>
+          <a:effectRef idx="2">
+            <a:schemeClr val="accent1"/>
+          </a:effectRef>
+          <a:fontRef idx="minor">
+            <a:schemeClr val="lt1"/>
+          </a:fontRef>
+        </p:style>
+        <p:txBody>
+          <a:bodyPr rtlCol="0" anchor="ctr"/>
+          <a:lstStyle/>
+          <a:p>
+            <a:pPr algn="ctr"/>
+          </a:p>
+        </p:txBody>
+      </p:sp>
+      <p:sp>
+        <p:nvSpPr>
+          <p:cNvPr id="16" name="TextBox 15"/>
+          <p:cNvSpPr txBox="1"/>
+          <p:nvPr/>
+        </p:nvSpPr>
+        <p:spPr>
+          <a:xfrm>
+            <a:off x="1243584" y="4251960"/>
+            <a:ext cx="3017520" cy="457200"/>
+          </a:xfrm>
+          <a:prstGeom prst="rect">
+            <a:avLst/>
+          </a:prstGeom>
+          <a:noFill/>
+        </p:spPr>
+        <p:txBody>
+          <a:bodyPr wrap="square" anchor="t" lIns="0" rIns="0" tIns="0" bIns="0">
+            <a:spAutoFit/>
+          </a:bodyPr>
+          <a:lstStyle/>
+          <a:p>
+            <a:pPr algn="l">
+              <a:lnSpc>
+                <a:spcPct val="105000"/>
+              </a:lnSpc>
+              <a:spcBef>
+                <a:spcPts val="0"/>
+              </a:spcBef>
+              <a:spcAft>
+                <a:spcPts val="400"/>
+              </a:spcAft>
+            </a:pPr>
+            <a:r>
+              <a:rPr sz="1650" b="1">
+                <a:solidFill>
+                  <a:srgbClr val="162A4A"/>
+                </a:solidFill>
+                <a:latin typeface="Calibri"/>
+              </a:rPr>
+              <a:t>CEO</a:t>
+            </a:r>
+          </a:p>
+        </p:txBody>
+      </p:sp>
+      <p:sp>
+        <p:nvSpPr>
+          <p:cNvPr id="17" name="TextBox 16"/>
+          <p:cNvSpPr txBox="1"/>
+          <p:nvPr/>
+        </p:nvSpPr>
+        <p:spPr>
+          <a:xfrm>
+            <a:off x="1243584" y="4663440"/>
+            <a:ext cx="3017520" cy="411480"/>
+          </a:xfrm>
+          <a:prstGeom prst="rect">
+            <a:avLst/>
+          </a:prstGeom>
+          <a:noFill/>
+        </p:spPr>
+        <p:txBody>
+          <a:bodyPr wrap="square" anchor="t" lIns="0" rIns="0" tIns="0" bIns="0">
+            <a:spAutoFit/>
+          </a:bodyPr>
+          <a:lstStyle/>
+          <a:p>
+            <a:pPr algn="l">
+              <a:lnSpc>
+                <a:spcPct val="105000"/>
+              </a:lnSpc>
+              <a:spcBef>
+                <a:spcPts val="0"/>
+              </a:spcBef>
+              <a:spcAft>
+                <a:spcPts val="400"/>
+              </a:spcAft>
+            </a:pPr>
+            <a:r>
+              <a:rPr sz="1250" b="0" i="1">
+                <a:solidFill>
+                  <a:srgbClr val="5B6B7B"/>
+                </a:solidFill>
+                <a:latin typeface="Calibri"/>
+              </a:rPr>
+              <a:t>hedges a graph posterior</a:t>
+            </a:r>
+          </a:p>
+        </p:txBody>
+      </p:sp>
+      <p:sp>
+        <p:nvSpPr>
+          <p:cNvPr id="18" name="TextBox 17"/>
+          <p:cNvSpPr txBox="1"/>
+          <p:nvPr/>
+        </p:nvSpPr>
+        <p:spPr>
+          <a:xfrm>
+            <a:off x="4434840" y="4224528"/>
+            <a:ext cx="6949440" cy="841248"/>
+          </a:xfrm>
+          <a:prstGeom prst="rect">
+            <a:avLst/>
+          </a:prstGeom>
+          <a:noFill/>
+        </p:spPr>
+        <p:txBody>
+          <a:bodyPr wrap="square" anchor="ctr" lIns="0" rIns="0" tIns="0" bIns="0">
+            <a:spAutoFit/>
+          </a:bodyPr>
+          <a:lstStyle/>
+          <a:p>
+            <a:pPr algn="l">
+              <a:lnSpc>
+                <a:spcPct val="110000"/>
+              </a:lnSpc>
+              <a:spcBef>
+                <a:spcPts val="0"/>
+              </a:spcBef>
+              <a:spcAft>
+                <a:spcPts val="400"/>
+              </a:spcAft>
+            </a:pPr>
+            <a:r>
+              <a:rPr sz="1300" b="0">
+                <a:solidFill>
+                  <a:srgbClr val="243242"/>
+                </a:solidFill>
+                <a:latin typeface="Calibri"/>
+              </a:rPr>
+              <a:t>Entropy acquisition over a candidate pool (authors' stack; pool contains the true DAG). Misspec sweep running — 90 LSF jobs; this slide auto-fills from the results JSON on rebuild.</a:t>
+            </a:r>
+          </a:p>
+        </p:txBody>
+      </p:sp>
+      <p:sp>
+        <p:nvSpPr>
+          <p:cNvPr id="19" name="Rounded Rectangle 18"/>
+          <p:cNvSpPr/>
+          <p:nvPr/>
+        </p:nvSpPr>
+        <p:spPr>
+          <a:xfrm>
+            <a:off x="548640" y="5303520"/>
+            <a:ext cx="11064240" cy="1042415"/>
+          </a:xfrm>
+          <a:prstGeom prst="roundRect">
+            <a:avLst>
+              <a:gd name="adj" fmla="val 6000"/>
+            </a:avLst>
+          </a:prstGeom>
+          <a:solidFill>
+            <a:srgbClr val="FFFFFF"/>
+          </a:solidFill>
+          <a:ln w="12700">
+            <a:solidFill>
+              <a:srgbClr val="D8DEE4"/>
+            </a:solidFill>
+          </a:ln>
+          <a:effectLst>
+            <a:outerShdw blurRad="90000" dist="38000" dir="5400000" rotWithShape="0">
+              <a:srgbClr val="9AA6B2">
+                <a:alpha val="26000"/>
+              </a:srgbClr>
+            </a:outerShdw>
+          </a:effectLst>
+        </p:spPr>
+        <p:style>
+          <a:lnRef idx="1">
+            <a:schemeClr val="accent1"/>
+          </a:lnRef>
+          <a:fillRef idx="3">
+            <a:schemeClr val="accent1"/>
+          </a:fillRef>
+          <a:effectRef idx="2">
+            <a:schemeClr val="accent1"/>
+          </a:effectRef>
+          <a:fontRef idx="minor">
+            <a:schemeClr val="lt1"/>
+          </a:fontRef>
+        </p:style>
+        <p:txBody>
+          <a:bodyPr rtlCol="0" anchor="ctr"/>
+          <a:lstStyle/>
+          <a:p>
+            <a:pPr algn="ctr"/>
+          </a:p>
+        </p:txBody>
+      </p:sp>
+      <p:sp>
+        <p:nvSpPr>
+          <p:cNvPr id="20" name="Oval 19"/>
+          <p:cNvSpPr/>
+          <p:nvPr/>
+        </p:nvSpPr>
+        <p:spPr>
+          <a:xfrm>
+            <a:off x="841248" y="5715000"/>
+            <a:ext cx="219456" cy="219456"/>
+          </a:xfrm>
+          <a:prstGeom prst="ellipse">
+            <a:avLst/>
+          </a:prstGeom>
+          <a:solidFill>
+            <a:srgbClr val="D55E00"/>
+          </a:solidFill>
+          <a:ln>
+            <a:noFill/>
+          </a:ln>
+          <a:effectLst/>
+        </p:spPr>
+        <p:style>
+          <a:lnRef idx="1">
+            <a:schemeClr val="accent1"/>
+          </a:lnRef>
+          <a:fillRef idx="3">
+            <a:schemeClr val="accent1"/>
+          </a:fillRef>
+          <a:effectRef idx="2">
+            <a:schemeClr val="accent1"/>
+          </a:effectRef>
+          <a:fontRef idx="minor">
+            <a:schemeClr val="lt1"/>
+          </a:fontRef>
+        </p:style>
+        <p:txBody>
+          <a:bodyPr rtlCol="0" anchor="ctr"/>
+          <a:lstStyle/>
+          <a:p>
+            <a:pPr algn="ctr"/>
+          </a:p>
+        </p:txBody>
+      </p:sp>
+      <p:sp>
+        <p:nvSpPr>
+          <p:cNvPr id="21" name="TextBox 20"/>
+          <p:cNvSpPr txBox="1"/>
+          <p:nvPr/>
+        </p:nvSpPr>
+        <p:spPr>
+          <a:xfrm>
+            <a:off x="1243584" y="5440680"/>
+            <a:ext cx="3017520" cy="457200"/>
+          </a:xfrm>
+          <a:prstGeom prst="rect">
+            <a:avLst/>
+          </a:prstGeom>
+          <a:noFill/>
+        </p:spPr>
+        <p:txBody>
+          <a:bodyPr wrap="square" anchor="t" lIns="0" rIns="0" tIns="0" bIns="0">
+            <a:spAutoFit/>
+          </a:bodyPr>
+          <a:lstStyle/>
+          <a:p>
+            <a:pPr algn="l">
+              <a:lnSpc>
+                <a:spcPct val="105000"/>
+              </a:lnSpc>
+              <a:spcBef>
+                <a:spcPts val="0"/>
+              </a:spcBef>
+              <a:spcAft>
+                <a:spcPts val="400"/>
+              </a:spcAft>
+            </a:pPr>
+            <a:r>
+              <a:rPr sz="1650" b="1">
+                <a:solidFill>
+                  <a:srgbClr val="162A4A"/>
+                </a:solidFill>
+                <a:latin typeface="Calibri"/>
+              </a:rPr>
+              <a:t>QCBO-coarse</a:t>
+            </a:r>
+          </a:p>
+        </p:txBody>
+      </p:sp>
+      <p:sp>
+        <p:nvSpPr>
+          <p:cNvPr id="22" name="TextBox 21"/>
+          <p:cNvSpPr txBox="1"/>
+          <p:nvPr/>
+        </p:nvSpPr>
+        <p:spPr>
+          <a:xfrm>
+            <a:off x="1243584" y="5852159"/>
+            <a:ext cx="3017520" cy="411480"/>
+          </a:xfrm>
+          <a:prstGeom prst="rect">
+            <a:avLst/>
+          </a:prstGeom>
+          <a:noFill/>
+        </p:spPr>
+        <p:txBody>
+          <a:bodyPr wrap="square" anchor="t" lIns="0" rIns="0" tIns="0" bIns="0">
+            <a:spAutoFit/>
+          </a:bodyPr>
+          <a:lstStyle/>
+          <a:p>
+            <a:pPr algn="l">
+              <a:lnSpc>
+                <a:spcPct val="105000"/>
+              </a:lnSpc>
+              <a:spcBef>
+                <a:spcPts val="0"/>
+              </a:spcBef>
+              <a:spcAft>
+                <a:spcPts val="400"/>
+              </a:spcAft>
+            </a:pPr>
+            <a:r>
+              <a:rPr sz="1250" b="0" i="1">
+                <a:solidFill>
+                  <a:srgbClr val="5B6B7B"/>
+                </a:solidFill>
+                <a:latin typeface="Calibri"/>
+              </a:rPr>
+              <a:t>commits to the quotient</a:t>
+            </a:r>
+          </a:p>
+        </p:txBody>
+      </p:sp>
+      <p:sp>
+        <p:nvSpPr>
+          <p:cNvPr id="23" name="TextBox 22"/>
+          <p:cNvSpPr txBox="1"/>
+          <p:nvPr/>
+        </p:nvSpPr>
+        <p:spPr>
+          <a:xfrm>
+            <a:off x="4434840" y="5413248"/>
+            <a:ext cx="6949440" cy="841248"/>
+          </a:xfrm>
+          <a:prstGeom prst="rect">
+            <a:avLst/>
+          </a:prstGeom>
+          <a:noFill/>
+        </p:spPr>
+        <p:txBody>
+          <a:bodyPr wrap="square" anchor="ctr" lIns="0" rIns="0" tIns="0" bIns="0">
+            <a:spAutoFit/>
+          </a:bodyPr>
+          <a:lstStyle/>
+          <a:p>
+            <a:pPr algn="l">
+              <a:lnSpc>
+                <a:spcPct val="110000"/>
+              </a:lnSpc>
+              <a:spcBef>
+                <a:spcPts val="0"/>
+              </a:spcBef>
+              <a:spcAft>
+                <a:spcPts val="400"/>
+              </a:spcAft>
+            </a:pPr>
+            <a:r>
+              <a:rPr sz="1300" b="0">
+                <a:solidFill>
+                  <a:srgbClr val="243242"/>
+                </a:solidFill>
+                <a:latin typeface="Calibri"/>
+              </a:rPr>
+              <a:t>Cannot represent intra-cluster structure, so intra-cluster errors cannot reach it: byte-identical trajectories (final Y 0.13, best of the field at P0).</a:t>
+            </a:r>
+          </a:p>
+        </p:txBody>
+      </p:sp>
+      <p:sp>
+        <p:nvSpPr>
+          <p:cNvPr id="24" name="TextBox 23"/>
+          <p:cNvSpPr txBox="1"/>
+          <p:nvPr/>
+        </p:nvSpPr>
+        <p:spPr>
+          <a:xfrm>
+            <a:off x="548640" y="6528816"/>
+            <a:ext cx="11064240" cy="292608"/>
+          </a:xfrm>
+          <a:prstGeom prst="rect">
+            <a:avLst/>
+          </a:prstGeom>
+          <a:noFill/>
+        </p:spPr>
+        <p:txBody>
+          <a:bodyPr wrap="square" anchor="t" lIns="0" rIns="0" tIns="0" bIns="0">
+            <a:spAutoFit/>
+          </a:bodyPr>
+          <a:lstStyle/>
+          <a:p>
+            <a:pPr algn="ctr">
+              <a:lnSpc>
+                <a:spcPct val="105000"/>
+              </a:lnSpc>
+              <a:spcBef>
+                <a:spcPts val="0"/>
+              </a:spcBef>
+              <a:spcAft>
+                <a:spcPts val="400"/>
+              </a:spcAft>
+            </a:pPr>
+            <a:r>
+              <a:rPr sz="1150" b="0" i="1">
+                <a:solidFill>
+                  <a:srgbClr val="5B6B7B"/>
+                </a:solidFill>
+                <a:latin typeface="Calibri"/>
+              </a:rPr>
+              <a:t>Same protocol for every row: true SCM fixed, structure injected, seam checks assert the objective is untouched.</a:t>
+            </a:r>
+          </a:p>
+        </p:txBody>
+      </p:sp>
+    </p:spTree>
+  </p:cSld>
+  <p:clrMapOvr>
+    <a:masterClrMapping/>
+  </p:clrMapOvr>
+</p:sld>
+</file>
+
+<file path=ppt/slides/slide9.xml><?xml version="1.0" encoding="utf-8"?>
 <p:sld xmlns:a="http://schemas.openxmlformats.org/drawingml/2006/main" xmlns:p="http://schemas.openxmlformats.org/presentationml/2006/main" xmlns:r="http://schemas.openxmlformats.org/officeDocument/2006/relationships">
   <p:cSld>
     <p:bg>

</xml_diff>